<commit_message>
Add monthly financial data and marketing spend history files
- Created a new CSV file `track_b_monthly_merged_table.csv` containing monthly financial metrics including Gross Revenue, COGS, Discounts, Shipping, Payment Fees, Net Revenue, Labor Cost, Rent, Storage Cost, Marketing Spend, and EBITDA metrics from January 2022 to November 2023.
- Added a new Excel file `marketing_spend_history.xlsx` for tracking marketing expenditures.
</commit_message>
<xml_diff>
--- a/Assessment_Center_Presentation_Template.pptx
+++ b/Assessment_Center_Presentation_Template.pptx
@@ -5,13 +5,26 @@
     <p:sldMasterId id="2147483648" r:id="rId4"/>
   </p:sldMasterIdLst>
   <p:notesMasterIdLst>
-    <p:notesMasterId r:id="rId6"/>
+    <p:notesMasterId r:id="rId19"/>
   </p:notesMasterIdLst>
   <p:handoutMasterIdLst>
-    <p:handoutMasterId r:id="rId7"/>
+    <p:handoutMasterId r:id="rId20"/>
   </p:handoutMasterIdLst>
   <p:sldIdLst>
     <p:sldId id="281" r:id="rId5"/>
+    <p:sldId id="282" r:id="rId6"/>
+    <p:sldId id="283" r:id="rId7"/>
+    <p:sldId id="284" r:id="rId8"/>
+    <p:sldId id="285" r:id="rId9"/>
+    <p:sldId id="286" r:id="rId10"/>
+    <p:sldId id="287" r:id="rId11"/>
+    <p:sldId id="288" r:id="rId12"/>
+    <p:sldId id="289" r:id="rId13"/>
+    <p:sldId id="290" r:id="rId14"/>
+    <p:sldId id="291" r:id="rId15"/>
+    <p:sldId id="292" r:id="rId16"/>
+    <p:sldId id="293" r:id="rId17"/>
+    <p:sldId id="294" r:id="rId18"/>
   </p:sldIdLst>
   <p:sldSz cx="12192000" cy="6858000"/>
   <p:notesSz cx="6858000" cy="9144000"/>
@@ -116,6 +129,19 @@
         <p14:section name="Default Section" id="{66CAFC65-CF18-4519-8C5D-309BC0A1460A}">
           <p14:sldIdLst>
             <p14:sldId id="281"/>
+            <p14:sldId id="282"/>
+            <p14:sldId id="283"/>
+            <p14:sldId id="284"/>
+            <p14:sldId id="285"/>
+            <p14:sldId id="286"/>
+            <p14:sldId id="287"/>
+            <p14:sldId id="288"/>
+            <p14:sldId id="289"/>
+            <p14:sldId id="290"/>
+            <p14:sldId id="291"/>
+            <p14:sldId id="292"/>
+            <p14:sldId id="293"/>
+            <p14:sldId id="294"/>
           </p14:sldIdLst>
         </p14:section>
       </p14:sectionLst>
@@ -6865,14 +6891,23 @@
         <p:spPr/>
         <p:txBody>
           <a:bodyPr>
-            <a:normAutofit fontScale="77500" lnSpcReduction="20000"/>
+            <a:normAutofit fontScale="70000" lnSpcReduction="20000"/>
           </a:bodyPr>
           <a:lstStyle/>
           <a:p>
             <a:r>
-              <a:rPr lang="en-US" dirty="0"/>
-              <a:t>Assessment Center Presentation Template</a:t>
-            </a:r>
+              <a:rPr lang="en-US" b="1" dirty="0"/>
+              <a:t>Zenith Active Solutions:</a:t>
+            </a:r>
+          </a:p>
+          <a:p>
+            <a:r>
+              <a:rPr lang="en-US" b="1" dirty="0"/>
+              <a:t> External Strategy Audit</a:t>
+            </a:r>
+          </a:p>
+          <a:p>
+            <a:endParaRPr lang="en-US" dirty="0"/>
           </a:p>
         </p:txBody>
       </p:sp>
@@ -7013,10 +7048,7 @@
             </a:lvl9pPr>
           </a:lstStyle>
           <a:p>
-            <a:r>
-              <a:rPr lang="en-US" dirty="0"/>
-              <a:t>Zenith</a:t>
-            </a:r>
+            <a:endParaRPr lang="en-US" dirty="0"/>
           </a:p>
         </p:txBody>
       </p:sp>
@@ -7024,6 +7056,3903 @@
     <p:extLst>
       <p:ext uri="{BB962C8B-B14F-4D97-AF65-F5344CB8AC3E}">
         <p14:creationId xmlns:p14="http://schemas.microsoft.com/office/powerpoint/2010/main" val="1901245648"/>
+      </p:ext>
+    </p:extLst>
+  </p:cSld>
+  <p:clrMapOvr>
+    <a:masterClrMapping/>
+  </p:clrMapOvr>
+</p:sld>
+</file>
+
+<file path=ppt/slides/slide10.xml><?xml version="1.0" encoding="utf-8"?>
+<p:sld xmlns:a="http://schemas.openxmlformats.org/drawingml/2006/main" xmlns:r="http://schemas.openxmlformats.org/officeDocument/2006/relationships" xmlns:p="http://schemas.openxmlformats.org/presentationml/2006/main">
+  <p:cSld>
+    <p:spTree>
+      <p:nvGrpSpPr>
+        <p:cNvPr id="1" name="">
+          <a:extLst>
+            <a:ext uri="{FF2B5EF4-FFF2-40B4-BE49-F238E27FC236}">
+              <a16:creationId xmlns:a16="http://schemas.microsoft.com/office/drawing/2014/main" id="{C8D13EB7-B28F-CA72-B4EB-E75D334D01BC}"/>
+            </a:ext>
+          </a:extLst>
+        </p:cNvPr>
+        <p:cNvGrpSpPr/>
+        <p:nvPr/>
+      </p:nvGrpSpPr>
+      <p:grpSpPr>
+        <a:xfrm>
+          <a:off x="0" y="0"/>
+          <a:ext cx="0" cy="0"/>
+          <a:chOff x="0" y="0"/>
+          <a:chExt cx="0" cy="0"/>
+        </a:xfrm>
+      </p:grpSpPr>
+      <p:pic>
+        <p:nvPicPr>
+          <p:cNvPr id="16" name="Picture 15" descr="A black background with pink dots&#10;&#10;AI-generated content may be incorrect.">
+            <a:extLst>
+              <a:ext uri="{FF2B5EF4-FFF2-40B4-BE49-F238E27FC236}">
+                <a16:creationId xmlns:a16="http://schemas.microsoft.com/office/drawing/2014/main" id="{7840545C-B44E-E728-A7F0-F754B1ED8B46}"/>
+              </a:ext>
+            </a:extLst>
+          </p:cNvPr>
+          <p:cNvPicPr>
+            <a:picLocks noChangeAspect="1"/>
+          </p:cNvPicPr>
+          <p:nvPr/>
+        </p:nvPicPr>
+        <p:blipFill>
+          <a:blip r:embed="rId2"/>
+          <a:stretch>
+            <a:fillRect/>
+          </a:stretch>
+        </p:blipFill>
+        <p:spPr>
+          <a:xfrm>
+            <a:off x="6096000" y="0"/>
+            <a:ext cx="6858000" cy="6858000"/>
+          </a:xfrm>
+          <a:prstGeom prst="rect">
+            <a:avLst/>
+          </a:prstGeom>
+        </p:spPr>
+      </p:pic>
+      <p:pic>
+        <p:nvPicPr>
+          <p:cNvPr id="15" name="Picture 14" descr="A black background with pink dots&#10;&#10;AI-generated content may be incorrect.">
+            <a:extLst>
+              <a:ext uri="{FF2B5EF4-FFF2-40B4-BE49-F238E27FC236}">
+                <a16:creationId xmlns:a16="http://schemas.microsoft.com/office/drawing/2014/main" id="{DCE56ECC-4C60-FFCE-45F4-D6F76CAAB66D}"/>
+              </a:ext>
+            </a:extLst>
+          </p:cNvPr>
+          <p:cNvPicPr>
+            <a:picLocks noChangeAspect="1"/>
+          </p:cNvPicPr>
+          <p:nvPr/>
+        </p:nvPicPr>
+        <p:blipFill>
+          <a:blip r:embed="rId2"/>
+          <a:stretch>
+            <a:fillRect/>
+          </a:stretch>
+        </p:blipFill>
+        <p:spPr>
+          <a:xfrm>
+            <a:off x="0" y="0"/>
+            <a:ext cx="6858000" cy="6858000"/>
+          </a:xfrm>
+          <a:prstGeom prst="rect">
+            <a:avLst/>
+          </a:prstGeom>
+        </p:spPr>
+      </p:pic>
+      <p:sp>
+        <p:nvSpPr>
+          <p:cNvPr id="2" name="Title 1">
+            <a:extLst>
+              <a:ext uri="{FF2B5EF4-FFF2-40B4-BE49-F238E27FC236}">
+                <a16:creationId xmlns:a16="http://schemas.microsoft.com/office/drawing/2014/main" id="{F9B6E9E9-A105-FFF8-0A97-19F324514532}"/>
+              </a:ext>
+            </a:extLst>
+          </p:cNvPr>
+          <p:cNvSpPr>
+            <a:spLocks noGrp="1"/>
+          </p:cNvSpPr>
+          <p:nvPr>
+            <p:ph type="ctrTitle"/>
+          </p:nvPr>
+        </p:nvSpPr>
+        <p:spPr/>
+        <p:txBody>
+          <a:bodyPr>
+            <a:noAutofit/>
+          </a:bodyPr>
+          <a:lstStyle/>
+          <a:p>
+            <a:r>
+              <a:rPr lang="en-US" sz="7200" dirty="0"/>
+              <a:t>Lumos</a:t>
+            </a:r>
+          </a:p>
+        </p:txBody>
+      </p:sp>
+      <p:sp>
+        <p:nvSpPr>
+          <p:cNvPr id="7" name="Text Placeholder 6">
+            <a:extLst>
+              <a:ext uri="{FF2B5EF4-FFF2-40B4-BE49-F238E27FC236}">
+                <a16:creationId xmlns:a16="http://schemas.microsoft.com/office/drawing/2014/main" id="{55352F20-5C5E-A0B1-EF57-F0C9124705E2}"/>
+              </a:ext>
+            </a:extLst>
+          </p:cNvPr>
+          <p:cNvSpPr>
+            <a:spLocks noGrp="1"/>
+          </p:cNvSpPr>
+          <p:nvPr>
+            <p:ph type="body" sz="quarter" idx="13"/>
+          </p:nvPr>
+        </p:nvSpPr>
+        <p:spPr/>
+        <p:txBody>
+          <a:bodyPr>
+            <a:normAutofit/>
+          </a:bodyPr>
+          <a:lstStyle/>
+          <a:p>
+            <a:r>
+              <a:rPr lang="en-US" dirty="0"/>
+              <a:t>Expected Impact</a:t>
+            </a:r>
+          </a:p>
+        </p:txBody>
+      </p:sp>
+      <p:sp>
+        <p:nvSpPr>
+          <p:cNvPr id="8" name="Slide Number Placeholder 7">
+            <a:extLst>
+              <a:ext uri="{FF2B5EF4-FFF2-40B4-BE49-F238E27FC236}">
+                <a16:creationId xmlns:a16="http://schemas.microsoft.com/office/drawing/2014/main" id="{4B97F733-E85B-192B-3934-CAEC2C8A89A8}"/>
+              </a:ext>
+            </a:extLst>
+          </p:cNvPr>
+          <p:cNvSpPr>
+            <a:spLocks noGrp="1"/>
+          </p:cNvSpPr>
+          <p:nvPr>
+            <p:ph type="sldNum" sz="quarter" idx="4294967295"/>
+          </p:nvPr>
+        </p:nvSpPr>
+        <p:spPr>
+          <a:xfrm>
+            <a:off x="10708715" y="6356350"/>
+            <a:ext cx="524479" cy="365125"/>
+          </a:xfrm>
+          <a:prstGeom prst="rect">
+            <a:avLst/>
+          </a:prstGeom>
+        </p:spPr>
+        <p:txBody>
+          <a:bodyPr/>
+          <a:lstStyle/>
+          <a:p>
+            <a:fld id="{777B4535-3FCB-194B-8628-80D28B32D103}" type="slidenum">
+              <a:rPr lang="en-US" smtClean="0"/>
+              <a:t>10</a:t>
+            </a:fld>
+            <a:endParaRPr lang="en-US"/>
+          </a:p>
+        </p:txBody>
+      </p:sp>
+      <p:pic>
+        <p:nvPicPr>
+          <p:cNvPr id="11" name="Picture 10" descr="A white logo on a black background&#10;&#10;AI-generated content may be incorrect.">
+            <a:extLst>
+              <a:ext uri="{FF2B5EF4-FFF2-40B4-BE49-F238E27FC236}">
+                <a16:creationId xmlns:a16="http://schemas.microsoft.com/office/drawing/2014/main" id="{3296F21A-D022-E2F9-4D14-ED2927B919D7}"/>
+              </a:ext>
+            </a:extLst>
+          </p:cNvPr>
+          <p:cNvPicPr>
+            <a:picLocks noChangeAspect="1"/>
+          </p:cNvPicPr>
+          <p:nvPr/>
+        </p:nvPicPr>
+        <p:blipFill>
+          <a:blip r:embed="rId3"/>
+          <a:stretch>
+            <a:fillRect/>
+          </a:stretch>
+        </p:blipFill>
+        <p:spPr>
+          <a:xfrm>
+            <a:off x="9986962" y="0"/>
+            <a:ext cx="2379427" cy="1043141"/>
+          </a:xfrm>
+          <a:prstGeom prst="rect">
+            <a:avLst/>
+          </a:prstGeom>
+        </p:spPr>
+      </p:pic>
+      <p:sp>
+        <p:nvSpPr>
+          <p:cNvPr id="3" name="Subtitle 2">
+            <a:extLst>
+              <a:ext uri="{FF2B5EF4-FFF2-40B4-BE49-F238E27FC236}">
+                <a16:creationId xmlns:a16="http://schemas.microsoft.com/office/drawing/2014/main" id="{9E9F9CD1-65B7-AFF2-C4DE-13DFDE0280A5}"/>
+              </a:ext>
+            </a:extLst>
+          </p:cNvPr>
+          <p:cNvSpPr>
+            <a:spLocks noGrp="1"/>
+          </p:cNvSpPr>
+          <p:nvPr>
+            <p:ph type="subTitle" idx="1" hasCustomPrompt="1"/>
+          </p:nvPr>
+        </p:nvSpPr>
+        <p:spPr>
+          <a:xfrm>
+            <a:off x="154112" y="3429000"/>
+            <a:ext cx="9144000" cy="588196"/>
+          </a:xfrm>
+        </p:spPr>
+        <p:txBody>
+          <a:bodyPr/>
+          <a:lstStyle>
+            <a:lvl1pPr marL="0" indent="0" algn="l">
+              <a:buNone/>
+              <a:defRPr sz="2400">
+                <a:solidFill>
+                  <a:schemeClr val="accent1">
+                    <a:lumMod val="20000"/>
+                    <a:lumOff val="80000"/>
+                  </a:schemeClr>
+                </a:solidFill>
+              </a:defRPr>
+            </a:lvl1pPr>
+            <a:lvl2pPr marL="457200" indent="0" algn="ctr">
+              <a:buNone/>
+              <a:defRPr sz="2000"/>
+            </a:lvl2pPr>
+            <a:lvl3pPr marL="914400" indent="0" algn="ctr">
+              <a:buNone/>
+              <a:defRPr sz="1800"/>
+            </a:lvl3pPr>
+            <a:lvl4pPr marL="1371600" indent="0" algn="ctr">
+              <a:buNone/>
+              <a:defRPr sz="1600"/>
+            </a:lvl4pPr>
+            <a:lvl5pPr marL="1828800" indent="0" algn="ctr">
+              <a:buNone/>
+              <a:defRPr sz="1600"/>
+            </a:lvl5pPr>
+            <a:lvl6pPr marL="2286000" indent="0" algn="ctr">
+              <a:buNone/>
+              <a:defRPr sz="1600"/>
+            </a:lvl6pPr>
+            <a:lvl7pPr marL="2743200" indent="0" algn="ctr">
+              <a:buNone/>
+              <a:defRPr sz="1600"/>
+            </a:lvl7pPr>
+            <a:lvl8pPr marL="3200400" indent="0" algn="ctr">
+              <a:buNone/>
+              <a:defRPr sz="1600"/>
+            </a:lvl8pPr>
+            <a:lvl9pPr marL="3657600" indent="0" algn="ctr">
+              <a:buNone/>
+              <a:defRPr sz="1600"/>
+            </a:lvl9pPr>
+          </a:lstStyle>
+          <a:p>
+            <a:r>
+              <a:rPr lang="en-US" dirty="0"/>
+              <a:t>Zenith</a:t>
+            </a:r>
+          </a:p>
+        </p:txBody>
+      </p:sp>
+    </p:spTree>
+    <p:extLst>
+      <p:ext uri="{BB962C8B-B14F-4D97-AF65-F5344CB8AC3E}">
+        <p14:creationId xmlns:p14="http://schemas.microsoft.com/office/powerpoint/2010/main" val="2919323948"/>
+      </p:ext>
+    </p:extLst>
+  </p:cSld>
+  <p:clrMapOvr>
+    <a:masterClrMapping/>
+  </p:clrMapOvr>
+</p:sld>
+</file>
+
+<file path=ppt/slides/slide11.xml><?xml version="1.0" encoding="utf-8"?>
+<p:sld xmlns:a="http://schemas.openxmlformats.org/drawingml/2006/main" xmlns:r="http://schemas.openxmlformats.org/officeDocument/2006/relationships" xmlns:p="http://schemas.openxmlformats.org/presentationml/2006/main">
+  <p:cSld>
+    <p:spTree>
+      <p:nvGrpSpPr>
+        <p:cNvPr id="1" name="">
+          <a:extLst>
+            <a:ext uri="{FF2B5EF4-FFF2-40B4-BE49-F238E27FC236}">
+              <a16:creationId xmlns:a16="http://schemas.microsoft.com/office/drawing/2014/main" id="{AFD38314-5D8C-26EE-8101-E4643461151A}"/>
+            </a:ext>
+          </a:extLst>
+        </p:cNvPr>
+        <p:cNvGrpSpPr/>
+        <p:nvPr/>
+      </p:nvGrpSpPr>
+      <p:grpSpPr>
+        <a:xfrm>
+          <a:off x="0" y="0"/>
+          <a:ext cx="0" cy="0"/>
+          <a:chOff x="0" y="0"/>
+          <a:chExt cx="0" cy="0"/>
+        </a:xfrm>
+      </p:grpSpPr>
+      <p:pic>
+        <p:nvPicPr>
+          <p:cNvPr id="16" name="Picture 15" descr="A black background with pink dots&#10;&#10;AI-generated content may be incorrect.">
+            <a:extLst>
+              <a:ext uri="{FF2B5EF4-FFF2-40B4-BE49-F238E27FC236}">
+                <a16:creationId xmlns:a16="http://schemas.microsoft.com/office/drawing/2014/main" id="{A18DFD1A-14BC-8567-1B86-DF8EBF550A2F}"/>
+              </a:ext>
+            </a:extLst>
+          </p:cNvPr>
+          <p:cNvPicPr>
+            <a:picLocks noChangeAspect="1"/>
+          </p:cNvPicPr>
+          <p:nvPr/>
+        </p:nvPicPr>
+        <p:blipFill>
+          <a:blip r:embed="rId2"/>
+          <a:stretch>
+            <a:fillRect/>
+          </a:stretch>
+        </p:blipFill>
+        <p:spPr>
+          <a:xfrm>
+            <a:off x="6096000" y="0"/>
+            <a:ext cx="6858000" cy="6858000"/>
+          </a:xfrm>
+          <a:prstGeom prst="rect">
+            <a:avLst/>
+          </a:prstGeom>
+        </p:spPr>
+      </p:pic>
+      <p:pic>
+        <p:nvPicPr>
+          <p:cNvPr id="15" name="Picture 14" descr="A black background with pink dots&#10;&#10;AI-generated content may be incorrect.">
+            <a:extLst>
+              <a:ext uri="{FF2B5EF4-FFF2-40B4-BE49-F238E27FC236}">
+                <a16:creationId xmlns:a16="http://schemas.microsoft.com/office/drawing/2014/main" id="{6D5C3A6B-FB49-5C50-2C38-B8AA344417CB}"/>
+              </a:ext>
+            </a:extLst>
+          </p:cNvPr>
+          <p:cNvPicPr>
+            <a:picLocks noChangeAspect="1"/>
+          </p:cNvPicPr>
+          <p:nvPr/>
+        </p:nvPicPr>
+        <p:blipFill>
+          <a:blip r:embed="rId2"/>
+          <a:stretch>
+            <a:fillRect/>
+          </a:stretch>
+        </p:blipFill>
+        <p:spPr>
+          <a:xfrm>
+            <a:off x="0" y="0"/>
+            <a:ext cx="6858000" cy="6858000"/>
+          </a:xfrm>
+          <a:prstGeom prst="rect">
+            <a:avLst/>
+          </a:prstGeom>
+        </p:spPr>
+      </p:pic>
+      <p:sp>
+        <p:nvSpPr>
+          <p:cNvPr id="2" name="Title 1">
+            <a:extLst>
+              <a:ext uri="{FF2B5EF4-FFF2-40B4-BE49-F238E27FC236}">
+                <a16:creationId xmlns:a16="http://schemas.microsoft.com/office/drawing/2014/main" id="{3A08FD3F-2F15-B01F-9E2F-4FD0C536DE22}"/>
+              </a:ext>
+            </a:extLst>
+          </p:cNvPr>
+          <p:cNvSpPr>
+            <a:spLocks noGrp="1"/>
+          </p:cNvSpPr>
+          <p:nvPr>
+            <p:ph type="ctrTitle"/>
+          </p:nvPr>
+        </p:nvSpPr>
+        <p:spPr/>
+        <p:txBody>
+          <a:bodyPr>
+            <a:noAutofit/>
+          </a:bodyPr>
+          <a:lstStyle/>
+          <a:p>
+            <a:r>
+              <a:rPr lang="en-US" sz="7200" dirty="0"/>
+              <a:t>Lumos</a:t>
+            </a:r>
+          </a:p>
+        </p:txBody>
+      </p:sp>
+      <p:sp>
+        <p:nvSpPr>
+          <p:cNvPr id="7" name="Text Placeholder 6">
+            <a:extLst>
+              <a:ext uri="{FF2B5EF4-FFF2-40B4-BE49-F238E27FC236}">
+                <a16:creationId xmlns:a16="http://schemas.microsoft.com/office/drawing/2014/main" id="{4F4E5E98-994E-1A38-D70D-C86B935487BD}"/>
+              </a:ext>
+            </a:extLst>
+          </p:cNvPr>
+          <p:cNvSpPr>
+            <a:spLocks noGrp="1"/>
+          </p:cNvSpPr>
+          <p:nvPr>
+            <p:ph type="body" sz="quarter" idx="13"/>
+          </p:nvPr>
+        </p:nvSpPr>
+        <p:spPr/>
+        <p:txBody>
+          <a:bodyPr>
+            <a:normAutofit/>
+          </a:bodyPr>
+          <a:lstStyle/>
+          <a:p>
+            <a:r>
+              <a:rPr lang="en-US" dirty="0"/>
+              <a:t>Expected Impact</a:t>
+            </a:r>
+          </a:p>
+        </p:txBody>
+      </p:sp>
+      <p:sp>
+        <p:nvSpPr>
+          <p:cNvPr id="8" name="Slide Number Placeholder 7">
+            <a:extLst>
+              <a:ext uri="{FF2B5EF4-FFF2-40B4-BE49-F238E27FC236}">
+                <a16:creationId xmlns:a16="http://schemas.microsoft.com/office/drawing/2014/main" id="{75D453C5-E16C-EF10-14EF-2DCC4CF36FD0}"/>
+              </a:ext>
+            </a:extLst>
+          </p:cNvPr>
+          <p:cNvSpPr>
+            <a:spLocks noGrp="1"/>
+          </p:cNvSpPr>
+          <p:nvPr>
+            <p:ph type="sldNum" sz="quarter" idx="4294967295"/>
+          </p:nvPr>
+        </p:nvSpPr>
+        <p:spPr>
+          <a:xfrm>
+            <a:off x="10708715" y="6356350"/>
+            <a:ext cx="524479" cy="365125"/>
+          </a:xfrm>
+          <a:prstGeom prst="rect">
+            <a:avLst/>
+          </a:prstGeom>
+        </p:spPr>
+        <p:txBody>
+          <a:bodyPr/>
+          <a:lstStyle/>
+          <a:p>
+            <a:fld id="{777B4535-3FCB-194B-8628-80D28B32D103}" type="slidenum">
+              <a:rPr lang="en-US" smtClean="0"/>
+              <a:t>11</a:t>
+            </a:fld>
+            <a:endParaRPr lang="en-US"/>
+          </a:p>
+        </p:txBody>
+      </p:sp>
+      <p:pic>
+        <p:nvPicPr>
+          <p:cNvPr id="11" name="Picture 10" descr="A white logo on a black background&#10;&#10;AI-generated content may be incorrect.">
+            <a:extLst>
+              <a:ext uri="{FF2B5EF4-FFF2-40B4-BE49-F238E27FC236}">
+                <a16:creationId xmlns:a16="http://schemas.microsoft.com/office/drawing/2014/main" id="{B4A0D7B8-A7A9-E29D-5F6E-C8282AD5C654}"/>
+              </a:ext>
+            </a:extLst>
+          </p:cNvPr>
+          <p:cNvPicPr>
+            <a:picLocks noChangeAspect="1"/>
+          </p:cNvPicPr>
+          <p:nvPr/>
+        </p:nvPicPr>
+        <p:blipFill>
+          <a:blip r:embed="rId3"/>
+          <a:stretch>
+            <a:fillRect/>
+          </a:stretch>
+        </p:blipFill>
+        <p:spPr>
+          <a:xfrm>
+            <a:off x="9986962" y="0"/>
+            <a:ext cx="2379427" cy="1043141"/>
+          </a:xfrm>
+          <a:prstGeom prst="rect">
+            <a:avLst/>
+          </a:prstGeom>
+        </p:spPr>
+      </p:pic>
+      <p:sp>
+        <p:nvSpPr>
+          <p:cNvPr id="3" name="Subtitle 2">
+            <a:extLst>
+              <a:ext uri="{FF2B5EF4-FFF2-40B4-BE49-F238E27FC236}">
+                <a16:creationId xmlns:a16="http://schemas.microsoft.com/office/drawing/2014/main" id="{121502A9-D0D2-9ED1-13F5-8FF881EA72DC}"/>
+              </a:ext>
+            </a:extLst>
+          </p:cNvPr>
+          <p:cNvSpPr>
+            <a:spLocks noGrp="1"/>
+          </p:cNvSpPr>
+          <p:nvPr>
+            <p:ph type="subTitle" idx="1" hasCustomPrompt="1"/>
+          </p:nvPr>
+        </p:nvSpPr>
+        <p:spPr>
+          <a:xfrm>
+            <a:off x="154112" y="3429000"/>
+            <a:ext cx="9144000" cy="588196"/>
+          </a:xfrm>
+        </p:spPr>
+        <p:txBody>
+          <a:bodyPr/>
+          <a:lstStyle>
+            <a:lvl1pPr marL="0" indent="0" algn="l">
+              <a:buNone/>
+              <a:defRPr sz="2400">
+                <a:solidFill>
+                  <a:schemeClr val="accent1">
+                    <a:lumMod val="20000"/>
+                    <a:lumOff val="80000"/>
+                  </a:schemeClr>
+                </a:solidFill>
+              </a:defRPr>
+            </a:lvl1pPr>
+            <a:lvl2pPr marL="457200" indent="0" algn="ctr">
+              <a:buNone/>
+              <a:defRPr sz="2000"/>
+            </a:lvl2pPr>
+            <a:lvl3pPr marL="914400" indent="0" algn="ctr">
+              <a:buNone/>
+              <a:defRPr sz="1800"/>
+            </a:lvl3pPr>
+            <a:lvl4pPr marL="1371600" indent="0" algn="ctr">
+              <a:buNone/>
+              <a:defRPr sz="1600"/>
+            </a:lvl4pPr>
+            <a:lvl5pPr marL="1828800" indent="0" algn="ctr">
+              <a:buNone/>
+              <a:defRPr sz="1600"/>
+            </a:lvl5pPr>
+            <a:lvl6pPr marL="2286000" indent="0" algn="ctr">
+              <a:buNone/>
+              <a:defRPr sz="1600"/>
+            </a:lvl6pPr>
+            <a:lvl7pPr marL="2743200" indent="0" algn="ctr">
+              <a:buNone/>
+              <a:defRPr sz="1600"/>
+            </a:lvl7pPr>
+            <a:lvl8pPr marL="3200400" indent="0" algn="ctr">
+              <a:buNone/>
+              <a:defRPr sz="1600"/>
+            </a:lvl8pPr>
+            <a:lvl9pPr marL="3657600" indent="0" algn="ctr">
+              <a:buNone/>
+              <a:defRPr sz="1600"/>
+            </a:lvl9pPr>
+          </a:lstStyle>
+          <a:p>
+            <a:r>
+              <a:rPr lang="en-US" dirty="0"/>
+              <a:t>Zenith</a:t>
+            </a:r>
+          </a:p>
+        </p:txBody>
+      </p:sp>
+    </p:spTree>
+    <p:extLst>
+      <p:ext uri="{BB962C8B-B14F-4D97-AF65-F5344CB8AC3E}">
+        <p14:creationId xmlns:p14="http://schemas.microsoft.com/office/powerpoint/2010/main" val="3547174016"/>
+      </p:ext>
+    </p:extLst>
+  </p:cSld>
+  <p:clrMapOvr>
+    <a:masterClrMapping/>
+  </p:clrMapOvr>
+</p:sld>
+</file>
+
+<file path=ppt/slides/slide12.xml><?xml version="1.0" encoding="utf-8"?>
+<p:sld xmlns:a="http://schemas.openxmlformats.org/drawingml/2006/main" xmlns:r="http://schemas.openxmlformats.org/officeDocument/2006/relationships" xmlns:p="http://schemas.openxmlformats.org/presentationml/2006/main">
+  <p:cSld>
+    <p:spTree>
+      <p:nvGrpSpPr>
+        <p:cNvPr id="1" name="">
+          <a:extLst>
+            <a:ext uri="{FF2B5EF4-FFF2-40B4-BE49-F238E27FC236}">
+              <a16:creationId xmlns:a16="http://schemas.microsoft.com/office/drawing/2014/main" id="{E2CFBF96-A469-58B3-DD86-B0B44B354A12}"/>
+            </a:ext>
+          </a:extLst>
+        </p:cNvPr>
+        <p:cNvGrpSpPr/>
+        <p:nvPr/>
+      </p:nvGrpSpPr>
+      <p:grpSpPr>
+        <a:xfrm>
+          <a:off x="0" y="0"/>
+          <a:ext cx="0" cy="0"/>
+          <a:chOff x="0" y="0"/>
+          <a:chExt cx="0" cy="0"/>
+        </a:xfrm>
+      </p:grpSpPr>
+      <p:pic>
+        <p:nvPicPr>
+          <p:cNvPr id="16" name="Picture 15" descr="A black background with pink dots&#10;&#10;AI-generated content may be incorrect.">
+            <a:extLst>
+              <a:ext uri="{FF2B5EF4-FFF2-40B4-BE49-F238E27FC236}">
+                <a16:creationId xmlns:a16="http://schemas.microsoft.com/office/drawing/2014/main" id="{9F673068-C944-A292-3CEB-934DDB8DA2BA}"/>
+              </a:ext>
+            </a:extLst>
+          </p:cNvPr>
+          <p:cNvPicPr>
+            <a:picLocks noChangeAspect="1"/>
+          </p:cNvPicPr>
+          <p:nvPr/>
+        </p:nvPicPr>
+        <p:blipFill>
+          <a:blip r:embed="rId2"/>
+          <a:stretch>
+            <a:fillRect/>
+          </a:stretch>
+        </p:blipFill>
+        <p:spPr>
+          <a:xfrm>
+            <a:off x="6096000" y="0"/>
+            <a:ext cx="6858000" cy="6858000"/>
+          </a:xfrm>
+          <a:prstGeom prst="rect">
+            <a:avLst/>
+          </a:prstGeom>
+        </p:spPr>
+      </p:pic>
+      <p:pic>
+        <p:nvPicPr>
+          <p:cNvPr id="15" name="Picture 14" descr="A black background with pink dots&#10;&#10;AI-generated content may be incorrect.">
+            <a:extLst>
+              <a:ext uri="{FF2B5EF4-FFF2-40B4-BE49-F238E27FC236}">
+                <a16:creationId xmlns:a16="http://schemas.microsoft.com/office/drawing/2014/main" id="{B1EC0AD0-BACA-9F94-702D-B6373AB2DA0C}"/>
+              </a:ext>
+            </a:extLst>
+          </p:cNvPr>
+          <p:cNvPicPr>
+            <a:picLocks noChangeAspect="1"/>
+          </p:cNvPicPr>
+          <p:nvPr/>
+        </p:nvPicPr>
+        <p:blipFill>
+          <a:blip r:embed="rId2"/>
+          <a:stretch>
+            <a:fillRect/>
+          </a:stretch>
+        </p:blipFill>
+        <p:spPr>
+          <a:xfrm>
+            <a:off x="0" y="0"/>
+            <a:ext cx="6858000" cy="6858000"/>
+          </a:xfrm>
+          <a:prstGeom prst="rect">
+            <a:avLst/>
+          </a:prstGeom>
+        </p:spPr>
+      </p:pic>
+      <p:sp>
+        <p:nvSpPr>
+          <p:cNvPr id="2" name="Title 1">
+            <a:extLst>
+              <a:ext uri="{FF2B5EF4-FFF2-40B4-BE49-F238E27FC236}">
+                <a16:creationId xmlns:a16="http://schemas.microsoft.com/office/drawing/2014/main" id="{85B7BF46-0F5E-4ED6-A34D-E3A3048BE138}"/>
+              </a:ext>
+            </a:extLst>
+          </p:cNvPr>
+          <p:cNvSpPr>
+            <a:spLocks noGrp="1"/>
+          </p:cNvSpPr>
+          <p:nvPr>
+            <p:ph type="ctrTitle"/>
+          </p:nvPr>
+        </p:nvSpPr>
+        <p:spPr/>
+        <p:txBody>
+          <a:bodyPr>
+            <a:noAutofit/>
+          </a:bodyPr>
+          <a:lstStyle/>
+          <a:p>
+            <a:r>
+              <a:rPr lang="en-US" sz="7200" dirty="0"/>
+              <a:t>Lumos</a:t>
+            </a:r>
+          </a:p>
+        </p:txBody>
+      </p:sp>
+      <p:sp>
+        <p:nvSpPr>
+          <p:cNvPr id="7" name="Text Placeholder 6">
+            <a:extLst>
+              <a:ext uri="{FF2B5EF4-FFF2-40B4-BE49-F238E27FC236}">
+                <a16:creationId xmlns:a16="http://schemas.microsoft.com/office/drawing/2014/main" id="{57557F51-9380-5A30-7B88-203888785AC2}"/>
+              </a:ext>
+            </a:extLst>
+          </p:cNvPr>
+          <p:cNvSpPr>
+            <a:spLocks noGrp="1"/>
+          </p:cNvSpPr>
+          <p:nvPr>
+            <p:ph type="body" sz="quarter" idx="13"/>
+          </p:nvPr>
+        </p:nvSpPr>
+        <p:spPr/>
+        <p:txBody>
+          <a:bodyPr>
+            <a:normAutofit/>
+          </a:bodyPr>
+          <a:lstStyle/>
+          <a:p>
+            <a:r>
+              <a:rPr lang="en-US" dirty="0"/>
+              <a:t>30-60-90 day plan</a:t>
+            </a:r>
+          </a:p>
+        </p:txBody>
+      </p:sp>
+      <p:sp>
+        <p:nvSpPr>
+          <p:cNvPr id="8" name="Slide Number Placeholder 7">
+            <a:extLst>
+              <a:ext uri="{FF2B5EF4-FFF2-40B4-BE49-F238E27FC236}">
+                <a16:creationId xmlns:a16="http://schemas.microsoft.com/office/drawing/2014/main" id="{DF196F06-8C4C-6E7E-B195-062369DB4658}"/>
+              </a:ext>
+            </a:extLst>
+          </p:cNvPr>
+          <p:cNvSpPr>
+            <a:spLocks noGrp="1"/>
+          </p:cNvSpPr>
+          <p:nvPr>
+            <p:ph type="sldNum" sz="quarter" idx="4294967295"/>
+          </p:nvPr>
+        </p:nvSpPr>
+        <p:spPr>
+          <a:xfrm>
+            <a:off x="10708715" y="6356350"/>
+            <a:ext cx="524479" cy="365125"/>
+          </a:xfrm>
+          <a:prstGeom prst="rect">
+            <a:avLst/>
+          </a:prstGeom>
+        </p:spPr>
+        <p:txBody>
+          <a:bodyPr/>
+          <a:lstStyle/>
+          <a:p>
+            <a:fld id="{777B4535-3FCB-194B-8628-80D28B32D103}" type="slidenum">
+              <a:rPr lang="en-US" smtClean="0"/>
+              <a:t>12</a:t>
+            </a:fld>
+            <a:endParaRPr lang="en-US"/>
+          </a:p>
+        </p:txBody>
+      </p:sp>
+      <p:pic>
+        <p:nvPicPr>
+          <p:cNvPr id="11" name="Picture 10" descr="A white logo on a black background&#10;&#10;AI-generated content may be incorrect.">
+            <a:extLst>
+              <a:ext uri="{FF2B5EF4-FFF2-40B4-BE49-F238E27FC236}">
+                <a16:creationId xmlns:a16="http://schemas.microsoft.com/office/drawing/2014/main" id="{65BBF904-4EEA-D419-8EC3-ED39F94065FC}"/>
+              </a:ext>
+            </a:extLst>
+          </p:cNvPr>
+          <p:cNvPicPr>
+            <a:picLocks noChangeAspect="1"/>
+          </p:cNvPicPr>
+          <p:nvPr/>
+        </p:nvPicPr>
+        <p:blipFill>
+          <a:blip r:embed="rId3"/>
+          <a:stretch>
+            <a:fillRect/>
+          </a:stretch>
+        </p:blipFill>
+        <p:spPr>
+          <a:xfrm>
+            <a:off x="9986962" y="0"/>
+            <a:ext cx="2379427" cy="1043141"/>
+          </a:xfrm>
+          <a:prstGeom prst="rect">
+            <a:avLst/>
+          </a:prstGeom>
+        </p:spPr>
+      </p:pic>
+      <p:sp>
+        <p:nvSpPr>
+          <p:cNvPr id="3" name="Subtitle 2">
+            <a:extLst>
+              <a:ext uri="{FF2B5EF4-FFF2-40B4-BE49-F238E27FC236}">
+                <a16:creationId xmlns:a16="http://schemas.microsoft.com/office/drawing/2014/main" id="{61AB81A8-97DA-466E-6BA7-6FD9F3A12F93}"/>
+              </a:ext>
+            </a:extLst>
+          </p:cNvPr>
+          <p:cNvSpPr>
+            <a:spLocks noGrp="1"/>
+          </p:cNvSpPr>
+          <p:nvPr>
+            <p:ph type="subTitle" idx="1" hasCustomPrompt="1"/>
+          </p:nvPr>
+        </p:nvSpPr>
+        <p:spPr>
+          <a:xfrm>
+            <a:off x="154112" y="3429000"/>
+            <a:ext cx="9144000" cy="588196"/>
+          </a:xfrm>
+        </p:spPr>
+        <p:txBody>
+          <a:bodyPr/>
+          <a:lstStyle>
+            <a:lvl1pPr marL="0" indent="0" algn="l">
+              <a:buNone/>
+              <a:defRPr sz="2400">
+                <a:solidFill>
+                  <a:schemeClr val="accent1">
+                    <a:lumMod val="20000"/>
+                    <a:lumOff val="80000"/>
+                  </a:schemeClr>
+                </a:solidFill>
+              </a:defRPr>
+            </a:lvl1pPr>
+            <a:lvl2pPr marL="457200" indent="0" algn="ctr">
+              <a:buNone/>
+              <a:defRPr sz="2000"/>
+            </a:lvl2pPr>
+            <a:lvl3pPr marL="914400" indent="0" algn="ctr">
+              <a:buNone/>
+              <a:defRPr sz="1800"/>
+            </a:lvl3pPr>
+            <a:lvl4pPr marL="1371600" indent="0" algn="ctr">
+              <a:buNone/>
+              <a:defRPr sz="1600"/>
+            </a:lvl4pPr>
+            <a:lvl5pPr marL="1828800" indent="0" algn="ctr">
+              <a:buNone/>
+              <a:defRPr sz="1600"/>
+            </a:lvl5pPr>
+            <a:lvl6pPr marL="2286000" indent="0" algn="ctr">
+              <a:buNone/>
+              <a:defRPr sz="1600"/>
+            </a:lvl6pPr>
+            <a:lvl7pPr marL="2743200" indent="0" algn="ctr">
+              <a:buNone/>
+              <a:defRPr sz="1600"/>
+            </a:lvl7pPr>
+            <a:lvl8pPr marL="3200400" indent="0" algn="ctr">
+              <a:buNone/>
+              <a:defRPr sz="1600"/>
+            </a:lvl8pPr>
+            <a:lvl9pPr marL="3657600" indent="0" algn="ctr">
+              <a:buNone/>
+              <a:defRPr sz="1600"/>
+            </a:lvl9pPr>
+          </a:lstStyle>
+          <a:p>
+            <a:r>
+              <a:rPr lang="en-US" dirty="0"/>
+              <a:t>Zenith</a:t>
+            </a:r>
+          </a:p>
+        </p:txBody>
+      </p:sp>
+    </p:spTree>
+    <p:extLst>
+      <p:ext uri="{BB962C8B-B14F-4D97-AF65-F5344CB8AC3E}">
+        <p14:creationId xmlns:p14="http://schemas.microsoft.com/office/powerpoint/2010/main" val="1265055649"/>
+      </p:ext>
+    </p:extLst>
+  </p:cSld>
+  <p:clrMapOvr>
+    <a:masterClrMapping/>
+  </p:clrMapOvr>
+</p:sld>
+</file>
+
+<file path=ppt/slides/slide13.xml><?xml version="1.0" encoding="utf-8"?>
+<p:sld xmlns:a="http://schemas.openxmlformats.org/drawingml/2006/main" xmlns:r="http://schemas.openxmlformats.org/officeDocument/2006/relationships" xmlns:p="http://schemas.openxmlformats.org/presentationml/2006/main">
+  <p:cSld>
+    <p:spTree>
+      <p:nvGrpSpPr>
+        <p:cNvPr id="1" name="">
+          <a:extLst>
+            <a:ext uri="{FF2B5EF4-FFF2-40B4-BE49-F238E27FC236}">
+              <a16:creationId xmlns:a16="http://schemas.microsoft.com/office/drawing/2014/main" id="{C50CDE95-2919-BA6A-1F8D-E842A219109A}"/>
+            </a:ext>
+          </a:extLst>
+        </p:cNvPr>
+        <p:cNvGrpSpPr/>
+        <p:nvPr/>
+      </p:nvGrpSpPr>
+      <p:grpSpPr>
+        <a:xfrm>
+          <a:off x="0" y="0"/>
+          <a:ext cx="0" cy="0"/>
+          <a:chOff x="0" y="0"/>
+          <a:chExt cx="0" cy="0"/>
+        </a:xfrm>
+      </p:grpSpPr>
+      <p:pic>
+        <p:nvPicPr>
+          <p:cNvPr id="16" name="Picture 15" descr="A black background with pink dots&#10;&#10;AI-generated content may be incorrect.">
+            <a:extLst>
+              <a:ext uri="{FF2B5EF4-FFF2-40B4-BE49-F238E27FC236}">
+                <a16:creationId xmlns:a16="http://schemas.microsoft.com/office/drawing/2014/main" id="{978568EC-33E8-2A02-456F-E8845F93EBB6}"/>
+              </a:ext>
+            </a:extLst>
+          </p:cNvPr>
+          <p:cNvPicPr>
+            <a:picLocks noChangeAspect="1"/>
+          </p:cNvPicPr>
+          <p:nvPr/>
+        </p:nvPicPr>
+        <p:blipFill>
+          <a:blip r:embed="rId2"/>
+          <a:stretch>
+            <a:fillRect/>
+          </a:stretch>
+        </p:blipFill>
+        <p:spPr>
+          <a:xfrm>
+            <a:off x="6096000" y="0"/>
+            <a:ext cx="6858000" cy="6858000"/>
+          </a:xfrm>
+          <a:prstGeom prst="rect">
+            <a:avLst/>
+          </a:prstGeom>
+        </p:spPr>
+      </p:pic>
+      <p:pic>
+        <p:nvPicPr>
+          <p:cNvPr id="15" name="Picture 14" descr="A black background with pink dots&#10;&#10;AI-generated content may be incorrect.">
+            <a:extLst>
+              <a:ext uri="{FF2B5EF4-FFF2-40B4-BE49-F238E27FC236}">
+                <a16:creationId xmlns:a16="http://schemas.microsoft.com/office/drawing/2014/main" id="{CC5BDF15-DD5A-CE09-9C91-A86199082BC1}"/>
+              </a:ext>
+            </a:extLst>
+          </p:cNvPr>
+          <p:cNvPicPr>
+            <a:picLocks noChangeAspect="1"/>
+          </p:cNvPicPr>
+          <p:nvPr/>
+        </p:nvPicPr>
+        <p:blipFill>
+          <a:blip r:embed="rId2"/>
+          <a:stretch>
+            <a:fillRect/>
+          </a:stretch>
+        </p:blipFill>
+        <p:spPr>
+          <a:xfrm>
+            <a:off x="0" y="0"/>
+            <a:ext cx="6858000" cy="6858000"/>
+          </a:xfrm>
+          <a:prstGeom prst="rect">
+            <a:avLst/>
+          </a:prstGeom>
+        </p:spPr>
+      </p:pic>
+      <p:sp>
+        <p:nvSpPr>
+          <p:cNvPr id="2" name="Title 1">
+            <a:extLst>
+              <a:ext uri="{FF2B5EF4-FFF2-40B4-BE49-F238E27FC236}">
+                <a16:creationId xmlns:a16="http://schemas.microsoft.com/office/drawing/2014/main" id="{E3590774-23DA-3F80-C720-FDDB0C1DE694}"/>
+              </a:ext>
+            </a:extLst>
+          </p:cNvPr>
+          <p:cNvSpPr>
+            <a:spLocks noGrp="1"/>
+          </p:cNvSpPr>
+          <p:nvPr>
+            <p:ph type="ctrTitle"/>
+          </p:nvPr>
+        </p:nvSpPr>
+        <p:spPr/>
+        <p:txBody>
+          <a:bodyPr>
+            <a:noAutofit/>
+          </a:bodyPr>
+          <a:lstStyle/>
+          <a:p>
+            <a:r>
+              <a:rPr lang="en-US" sz="7200" dirty="0"/>
+              <a:t>Lumos</a:t>
+            </a:r>
+          </a:p>
+        </p:txBody>
+      </p:sp>
+      <p:sp>
+        <p:nvSpPr>
+          <p:cNvPr id="7" name="Text Placeholder 6">
+            <a:extLst>
+              <a:ext uri="{FF2B5EF4-FFF2-40B4-BE49-F238E27FC236}">
+                <a16:creationId xmlns:a16="http://schemas.microsoft.com/office/drawing/2014/main" id="{0B99D276-17C2-D84D-B30D-4A9591117B53}"/>
+              </a:ext>
+            </a:extLst>
+          </p:cNvPr>
+          <p:cNvSpPr>
+            <a:spLocks noGrp="1"/>
+          </p:cNvSpPr>
+          <p:nvPr>
+            <p:ph type="body" sz="quarter" idx="13"/>
+          </p:nvPr>
+        </p:nvSpPr>
+        <p:spPr/>
+        <p:txBody>
+          <a:bodyPr>
+            <a:normAutofit/>
+          </a:bodyPr>
+          <a:lstStyle/>
+          <a:p>
+            <a:r>
+              <a:rPr lang="en-US" dirty="0"/>
+              <a:t>30-60-90 day plan</a:t>
+            </a:r>
+          </a:p>
+        </p:txBody>
+      </p:sp>
+      <p:sp>
+        <p:nvSpPr>
+          <p:cNvPr id="8" name="Slide Number Placeholder 7">
+            <a:extLst>
+              <a:ext uri="{FF2B5EF4-FFF2-40B4-BE49-F238E27FC236}">
+                <a16:creationId xmlns:a16="http://schemas.microsoft.com/office/drawing/2014/main" id="{A1F1DA13-31BB-E54B-4BA9-0AAF95981E3C}"/>
+              </a:ext>
+            </a:extLst>
+          </p:cNvPr>
+          <p:cNvSpPr>
+            <a:spLocks noGrp="1"/>
+          </p:cNvSpPr>
+          <p:nvPr>
+            <p:ph type="sldNum" sz="quarter" idx="4294967295"/>
+          </p:nvPr>
+        </p:nvSpPr>
+        <p:spPr>
+          <a:xfrm>
+            <a:off x="10708715" y="6356350"/>
+            <a:ext cx="524479" cy="365125"/>
+          </a:xfrm>
+          <a:prstGeom prst="rect">
+            <a:avLst/>
+          </a:prstGeom>
+        </p:spPr>
+        <p:txBody>
+          <a:bodyPr/>
+          <a:lstStyle/>
+          <a:p>
+            <a:fld id="{777B4535-3FCB-194B-8628-80D28B32D103}" type="slidenum">
+              <a:rPr lang="en-US" smtClean="0"/>
+              <a:t>13</a:t>
+            </a:fld>
+            <a:endParaRPr lang="en-US"/>
+          </a:p>
+        </p:txBody>
+      </p:sp>
+      <p:pic>
+        <p:nvPicPr>
+          <p:cNvPr id="11" name="Picture 10" descr="A white logo on a black background&#10;&#10;AI-generated content may be incorrect.">
+            <a:extLst>
+              <a:ext uri="{FF2B5EF4-FFF2-40B4-BE49-F238E27FC236}">
+                <a16:creationId xmlns:a16="http://schemas.microsoft.com/office/drawing/2014/main" id="{C2B2B3EC-F39A-DAB0-6669-E6390C173C06}"/>
+              </a:ext>
+            </a:extLst>
+          </p:cNvPr>
+          <p:cNvPicPr>
+            <a:picLocks noChangeAspect="1"/>
+          </p:cNvPicPr>
+          <p:nvPr/>
+        </p:nvPicPr>
+        <p:blipFill>
+          <a:blip r:embed="rId3"/>
+          <a:stretch>
+            <a:fillRect/>
+          </a:stretch>
+        </p:blipFill>
+        <p:spPr>
+          <a:xfrm>
+            <a:off x="9986962" y="0"/>
+            <a:ext cx="2379427" cy="1043141"/>
+          </a:xfrm>
+          <a:prstGeom prst="rect">
+            <a:avLst/>
+          </a:prstGeom>
+        </p:spPr>
+      </p:pic>
+      <p:sp>
+        <p:nvSpPr>
+          <p:cNvPr id="3" name="Subtitle 2">
+            <a:extLst>
+              <a:ext uri="{FF2B5EF4-FFF2-40B4-BE49-F238E27FC236}">
+                <a16:creationId xmlns:a16="http://schemas.microsoft.com/office/drawing/2014/main" id="{0F76BA00-3933-CD44-B861-2BE4442B7B5C}"/>
+              </a:ext>
+            </a:extLst>
+          </p:cNvPr>
+          <p:cNvSpPr>
+            <a:spLocks noGrp="1"/>
+          </p:cNvSpPr>
+          <p:nvPr>
+            <p:ph type="subTitle" idx="1" hasCustomPrompt="1"/>
+          </p:nvPr>
+        </p:nvSpPr>
+        <p:spPr>
+          <a:xfrm>
+            <a:off x="154112" y="3429000"/>
+            <a:ext cx="9144000" cy="588196"/>
+          </a:xfrm>
+        </p:spPr>
+        <p:txBody>
+          <a:bodyPr/>
+          <a:lstStyle>
+            <a:lvl1pPr marL="0" indent="0" algn="l">
+              <a:buNone/>
+              <a:defRPr sz="2400">
+                <a:solidFill>
+                  <a:schemeClr val="accent1">
+                    <a:lumMod val="20000"/>
+                    <a:lumOff val="80000"/>
+                  </a:schemeClr>
+                </a:solidFill>
+              </a:defRPr>
+            </a:lvl1pPr>
+            <a:lvl2pPr marL="457200" indent="0" algn="ctr">
+              <a:buNone/>
+              <a:defRPr sz="2000"/>
+            </a:lvl2pPr>
+            <a:lvl3pPr marL="914400" indent="0" algn="ctr">
+              <a:buNone/>
+              <a:defRPr sz="1800"/>
+            </a:lvl3pPr>
+            <a:lvl4pPr marL="1371600" indent="0" algn="ctr">
+              <a:buNone/>
+              <a:defRPr sz="1600"/>
+            </a:lvl4pPr>
+            <a:lvl5pPr marL="1828800" indent="0" algn="ctr">
+              <a:buNone/>
+              <a:defRPr sz="1600"/>
+            </a:lvl5pPr>
+            <a:lvl6pPr marL="2286000" indent="0" algn="ctr">
+              <a:buNone/>
+              <a:defRPr sz="1600"/>
+            </a:lvl6pPr>
+            <a:lvl7pPr marL="2743200" indent="0" algn="ctr">
+              <a:buNone/>
+              <a:defRPr sz="1600"/>
+            </a:lvl7pPr>
+            <a:lvl8pPr marL="3200400" indent="0" algn="ctr">
+              <a:buNone/>
+              <a:defRPr sz="1600"/>
+            </a:lvl8pPr>
+            <a:lvl9pPr marL="3657600" indent="0" algn="ctr">
+              <a:buNone/>
+              <a:defRPr sz="1600"/>
+            </a:lvl9pPr>
+          </a:lstStyle>
+          <a:p>
+            <a:r>
+              <a:rPr lang="en-US" dirty="0"/>
+              <a:t>Zenith</a:t>
+            </a:r>
+          </a:p>
+        </p:txBody>
+      </p:sp>
+    </p:spTree>
+    <p:extLst>
+      <p:ext uri="{BB962C8B-B14F-4D97-AF65-F5344CB8AC3E}">
+        <p14:creationId xmlns:p14="http://schemas.microsoft.com/office/powerpoint/2010/main" val="1182541531"/>
+      </p:ext>
+    </p:extLst>
+  </p:cSld>
+  <p:clrMapOvr>
+    <a:masterClrMapping/>
+  </p:clrMapOvr>
+</p:sld>
+</file>
+
+<file path=ppt/slides/slide14.xml><?xml version="1.0" encoding="utf-8"?>
+<p:sld xmlns:a="http://schemas.openxmlformats.org/drawingml/2006/main" xmlns:r="http://schemas.openxmlformats.org/officeDocument/2006/relationships" xmlns:p="http://schemas.openxmlformats.org/presentationml/2006/main">
+  <p:cSld>
+    <p:spTree>
+      <p:nvGrpSpPr>
+        <p:cNvPr id="1" name="">
+          <a:extLst>
+            <a:ext uri="{FF2B5EF4-FFF2-40B4-BE49-F238E27FC236}">
+              <a16:creationId xmlns:a16="http://schemas.microsoft.com/office/drawing/2014/main" id="{DCF999CC-BEBC-B63D-8747-DECD253155EA}"/>
+            </a:ext>
+          </a:extLst>
+        </p:cNvPr>
+        <p:cNvGrpSpPr/>
+        <p:nvPr/>
+      </p:nvGrpSpPr>
+      <p:grpSpPr>
+        <a:xfrm>
+          <a:off x="0" y="0"/>
+          <a:ext cx="0" cy="0"/>
+          <a:chOff x="0" y="0"/>
+          <a:chExt cx="0" cy="0"/>
+        </a:xfrm>
+      </p:grpSpPr>
+      <p:pic>
+        <p:nvPicPr>
+          <p:cNvPr id="16" name="Picture 15" descr="A black background with pink dots&#10;&#10;AI-generated content may be incorrect.">
+            <a:extLst>
+              <a:ext uri="{FF2B5EF4-FFF2-40B4-BE49-F238E27FC236}">
+                <a16:creationId xmlns:a16="http://schemas.microsoft.com/office/drawing/2014/main" id="{B6DD1AD1-7A1C-A9BB-B802-069535EEA8EA}"/>
+              </a:ext>
+            </a:extLst>
+          </p:cNvPr>
+          <p:cNvPicPr>
+            <a:picLocks noChangeAspect="1"/>
+          </p:cNvPicPr>
+          <p:nvPr/>
+        </p:nvPicPr>
+        <p:blipFill>
+          <a:blip r:embed="rId2"/>
+          <a:stretch>
+            <a:fillRect/>
+          </a:stretch>
+        </p:blipFill>
+        <p:spPr>
+          <a:xfrm>
+            <a:off x="6096000" y="0"/>
+            <a:ext cx="6858000" cy="6858000"/>
+          </a:xfrm>
+          <a:prstGeom prst="rect">
+            <a:avLst/>
+          </a:prstGeom>
+        </p:spPr>
+      </p:pic>
+      <p:pic>
+        <p:nvPicPr>
+          <p:cNvPr id="15" name="Picture 14" descr="A black background with pink dots&#10;&#10;AI-generated content may be incorrect.">
+            <a:extLst>
+              <a:ext uri="{FF2B5EF4-FFF2-40B4-BE49-F238E27FC236}">
+                <a16:creationId xmlns:a16="http://schemas.microsoft.com/office/drawing/2014/main" id="{48101936-4739-EAF2-9480-74D6A84C2AD4}"/>
+              </a:ext>
+            </a:extLst>
+          </p:cNvPr>
+          <p:cNvPicPr>
+            <a:picLocks noChangeAspect="1"/>
+          </p:cNvPicPr>
+          <p:nvPr/>
+        </p:nvPicPr>
+        <p:blipFill>
+          <a:blip r:embed="rId2"/>
+          <a:stretch>
+            <a:fillRect/>
+          </a:stretch>
+        </p:blipFill>
+        <p:spPr>
+          <a:xfrm>
+            <a:off x="0" y="0"/>
+            <a:ext cx="6858000" cy="6858000"/>
+          </a:xfrm>
+          <a:prstGeom prst="rect">
+            <a:avLst/>
+          </a:prstGeom>
+        </p:spPr>
+      </p:pic>
+      <p:sp>
+        <p:nvSpPr>
+          <p:cNvPr id="2" name="Title 1">
+            <a:extLst>
+              <a:ext uri="{FF2B5EF4-FFF2-40B4-BE49-F238E27FC236}">
+                <a16:creationId xmlns:a16="http://schemas.microsoft.com/office/drawing/2014/main" id="{66945928-CE07-25B6-1035-3D1DE6A69B15}"/>
+              </a:ext>
+            </a:extLst>
+          </p:cNvPr>
+          <p:cNvSpPr>
+            <a:spLocks noGrp="1"/>
+          </p:cNvSpPr>
+          <p:nvPr>
+            <p:ph type="ctrTitle"/>
+          </p:nvPr>
+        </p:nvSpPr>
+        <p:spPr/>
+        <p:txBody>
+          <a:bodyPr>
+            <a:noAutofit/>
+          </a:bodyPr>
+          <a:lstStyle/>
+          <a:p>
+            <a:r>
+              <a:rPr lang="en-US" sz="7200" dirty="0"/>
+              <a:t>Lumos</a:t>
+            </a:r>
+          </a:p>
+        </p:txBody>
+      </p:sp>
+      <p:sp>
+        <p:nvSpPr>
+          <p:cNvPr id="7" name="Text Placeholder 6">
+            <a:extLst>
+              <a:ext uri="{FF2B5EF4-FFF2-40B4-BE49-F238E27FC236}">
+                <a16:creationId xmlns:a16="http://schemas.microsoft.com/office/drawing/2014/main" id="{CF8DAE85-31C1-4E3A-B73E-AFB1697E45F5}"/>
+              </a:ext>
+            </a:extLst>
+          </p:cNvPr>
+          <p:cNvSpPr>
+            <a:spLocks noGrp="1"/>
+          </p:cNvSpPr>
+          <p:nvPr>
+            <p:ph type="body" sz="quarter" idx="13"/>
+          </p:nvPr>
+        </p:nvSpPr>
+        <p:spPr/>
+        <p:txBody>
+          <a:bodyPr>
+            <a:normAutofit/>
+          </a:bodyPr>
+          <a:lstStyle/>
+          <a:p>
+            <a:r>
+              <a:rPr lang="en-US" dirty="0"/>
+              <a:t>30-60-90 day plan</a:t>
+            </a:r>
+          </a:p>
+        </p:txBody>
+      </p:sp>
+      <p:sp>
+        <p:nvSpPr>
+          <p:cNvPr id="8" name="Slide Number Placeholder 7">
+            <a:extLst>
+              <a:ext uri="{FF2B5EF4-FFF2-40B4-BE49-F238E27FC236}">
+                <a16:creationId xmlns:a16="http://schemas.microsoft.com/office/drawing/2014/main" id="{C9EC7D3E-5F1B-45F6-9D6A-DFBF01333739}"/>
+              </a:ext>
+            </a:extLst>
+          </p:cNvPr>
+          <p:cNvSpPr>
+            <a:spLocks noGrp="1"/>
+          </p:cNvSpPr>
+          <p:nvPr>
+            <p:ph type="sldNum" sz="quarter" idx="4294967295"/>
+          </p:nvPr>
+        </p:nvSpPr>
+        <p:spPr>
+          <a:xfrm>
+            <a:off x="10708715" y="6356350"/>
+            <a:ext cx="524479" cy="365125"/>
+          </a:xfrm>
+          <a:prstGeom prst="rect">
+            <a:avLst/>
+          </a:prstGeom>
+        </p:spPr>
+        <p:txBody>
+          <a:bodyPr/>
+          <a:lstStyle/>
+          <a:p>
+            <a:fld id="{777B4535-3FCB-194B-8628-80D28B32D103}" type="slidenum">
+              <a:rPr lang="en-US" smtClean="0"/>
+              <a:t>14</a:t>
+            </a:fld>
+            <a:endParaRPr lang="en-US"/>
+          </a:p>
+        </p:txBody>
+      </p:sp>
+      <p:pic>
+        <p:nvPicPr>
+          <p:cNvPr id="11" name="Picture 10" descr="A white logo on a black background&#10;&#10;AI-generated content may be incorrect.">
+            <a:extLst>
+              <a:ext uri="{FF2B5EF4-FFF2-40B4-BE49-F238E27FC236}">
+                <a16:creationId xmlns:a16="http://schemas.microsoft.com/office/drawing/2014/main" id="{AE4461A7-C706-129F-7288-0BD6E4A3D2DB}"/>
+              </a:ext>
+            </a:extLst>
+          </p:cNvPr>
+          <p:cNvPicPr>
+            <a:picLocks noChangeAspect="1"/>
+          </p:cNvPicPr>
+          <p:nvPr/>
+        </p:nvPicPr>
+        <p:blipFill>
+          <a:blip r:embed="rId3"/>
+          <a:stretch>
+            <a:fillRect/>
+          </a:stretch>
+        </p:blipFill>
+        <p:spPr>
+          <a:xfrm>
+            <a:off x="9986962" y="0"/>
+            <a:ext cx="2379427" cy="1043141"/>
+          </a:xfrm>
+          <a:prstGeom prst="rect">
+            <a:avLst/>
+          </a:prstGeom>
+        </p:spPr>
+      </p:pic>
+      <p:sp>
+        <p:nvSpPr>
+          <p:cNvPr id="3" name="Subtitle 2">
+            <a:extLst>
+              <a:ext uri="{FF2B5EF4-FFF2-40B4-BE49-F238E27FC236}">
+                <a16:creationId xmlns:a16="http://schemas.microsoft.com/office/drawing/2014/main" id="{BA2A2F62-B8F3-366E-8BB1-173B016E8572}"/>
+              </a:ext>
+            </a:extLst>
+          </p:cNvPr>
+          <p:cNvSpPr>
+            <a:spLocks noGrp="1"/>
+          </p:cNvSpPr>
+          <p:nvPr>
+            <p:ph type="subTitle" idx="1" hasCustomPrompt="1"/>
+          </p:nvPr>
+        </p:nvSpPr>
+        <p:spPr>
+          <a:xfrm>
+            <a:off x="154112" y="3429000"/>
+            <a:ext cx="9144000" cy="588196"/>
+          </a:xfrm>
+        </p:spPr>
+        <p:txBody>
+          <a:bodyPr/>
+          <a:lstStyle>
+            <a:lvl1pPr marL="0" indent="0" algn="l">
+              <a:buNone/>
+              <a:defRPr sz="2400">
+                <a:solidFill>
+                  <a:schemeClr val="accent1">
+                    <a:lumMod val="20000"/>
+                    <a:lumOff val="80000"/>
+                  </a:schemeClr>
+                </a:solidFill>
+              </a:defRPr>
+            </a:lvl1pPr>
+            <a:lvl2pPr marL="457200" indent="0" algn="ctr">
+              <a:buNone/>
+              <a:defRPr sz="2000"/>
+            </a:lvl2pPr>
+            <a:lvl3pPr marL="914400" indent="0" algn="ctr">
+              <a:buNone/>
+              <a:defRPr sz="1800"/>
+            </a:lvl3pPr>
+            <a:lvl4pPr marL="1371600" indent="0" algn="ctr">
+              <a:buNone/>
+              <a:defRPr sz="1600"/>
+            </a:lvl4pPr>
+            <a:lvl5pPr marL="1828800" indent="0" algn="ctr">
+              <a:buNone/>
+              <a:defRPr sz="1600"/>
+            </a:lvl5pPr>
+            <a:lvl6pPr marL="2286000" indent="0" algn="ctr">
+              <a:buNone/>
+              <a:defRPr sz="1600"/>
+            </a:lvl6pPr>
+            <a:lvl7pPr marL="2743200" indent="0" algn="ctr">
+              <a:buNone/>
+              <a:defRPr sz="1600"/>
+            </a:lvl7pPr>
+            <a:lvl8pPr marL="3200400" indent="0" algn="ctr">
+              <a:buNone/>
+              <a:defRPr sz="1600"/>
+            </a:lvl8pPr>
+            <a:lvl9pPr marL="3657600" indent="0" algn="ctr">
+              <a:buNone/>
+              <a:defRPr sz="1600"/>
+            </a:lvl9pPr>
+          </a:lstStyle>
+          <a:p>
+            <a:r>
+              <a:rPr lang="en-US" dirty="0"/>
+              <a:t>Zenith</a:t>
+            </a:r>
+          </a:p>
+        </p:txBody>
+      </p:sp>
+    </p:spTree>
+    <p:extLst>
+      <p:ext uri="{BB962C8B-B14F-4D97-AF65-F5344CB8AC3E}">
+        <p14:creationId xmlns:p14="http://schemas.microsoft.com/office/powerpoint/2010/main" val="641824345"/>
+      </p:ext>
+    </p:extLst>
+  </p:cSld>
+  <p:clrMapOvr>
+    <a:masterClrMapping/>
+  </p:clrMapOvr>
+</p:sld>
+</file>
+
+<file path=ppt/slides/slide2.xml><?xml version="1.0" encoding="utf-8"?>
+<p:sld xmlns:a="http://schemas.openxmlformats.org/drawingml/2006/main" xmlns:r="http://schemas.openxmlformats.org/officeDocument/2006/relationships" xmlns:p="http://schemas.openxmlformats.org/presentationml/2006/main">
+  <p:cSld>
+    <p:spTree>
+      <p:nvGrpSpPr>
+        <p:cNvPr id="1" name="">
+          <a:extLst>
+            <a:ext uri="{FF2B5EF4-FFF2-40B4-BE49-F238E27FC236}">
+              <a16:creationId xmlns:a16="http://schemas.microsoft.com/office/drawing/2014/main" id="{00856B7A-5759-50EC-7F28-5C56CC3E2C76}"/>
+            </a:ext>
+          </a:extLst>
+        </p:cNvPr>
+        <p:cNvGrpSpPr/>
+        <p:nvPr/>
+      </p:nvGrpSpPr>
+      <p:grpSpPr>
+        <a:xfrm>
+          <a:off x="0" y="0"/>
+          <a:ext cx="0" cy="0"/>
+          <a:chOff x="0" y="0"/>
+          <a:chExt cx="0" cy="0"/>
+        </a:xfrm>
+      </p:grpSpPr>
+      <p:pic>
+        <p:nvPicPr>
+          <p:cNvPr id="16" name="Picture 15" descr="A black background with pink dots&#10;&#10;AI-generated content may be incorrect.">
+            <a:extLst>
+              <a:ext uri="{FF2B5EF4-FFF2-40B4-BE49-F238E27FC236}">
+                <a16:creationId xmlns:a16="http://schemas.microsoft.com/office/drawing/2014/main" id="{F1CD4AF7-EF4E-FC51-B5B4-484B79D8C9FF}"/>
+              </a:ext>
+            </a:extLst>
+          </p:cNvPr>
+          <p:cNvPicPr>
+            <a:picLocks noChangeAspect="1"/>
+          </p:cNvPicPr>
+          <p:nvPr/>
+        </p:nvPicPr>
+        <p:blipFill>
+          <a:blip r:embed="rId2"/>
+          <a:stretch>
+            <a:fillRect/>
+          </a:stretch>
+        </p:blipFill>
+        <p:spPr>
+          <a:xfrm>
+            <a:off x="6096000" y="0"/>
+            <a:ext cx="6858000" cy="6858000"/>
+          </a:xfrm>
+          <a:prstGeom prst="rect">
+            <a:avLst/>
+          </a:prstGeom>
+        </p:spPr>
+      </p:pic>
+      <p:pic>
+        <p:nvPicPr>
+          <p:cNvPr id="15" name="Picture 14" descr="A black background with pink dots&#10;&#10;AI-generated content may be incorrect.">
+            <a:extLst>
+              <a:ext uri="{FF2B5EF4-FFF2-40B4-BE49-F238E27FC236}">
+                <a16:creationId xmlns:a16="http://schemas.microsoft.com/office/drawing/2014/main" id="{D8D23B1C-E7E8-29B8-7BEB-080F54D3DB27}"/>
+              </a:ext>
+            </a:extLst>
+          </p:cNvPr>
+          <p:cNvPicPr>
+            <a:picLocks noChangeAspect="1"/>
+          </p:cNvPicPr>
+          <p:nvPr/>
+        </p:nvPicPr>
+        <p:blipFill>
+          <a:blip r:embed="rId2"/>
+          <a:stretch>
+            <a:fillRect/>
+          </a:stretch>
+        </p:blipFill>
+        <p:spPr>
+          <a:xfrm>
+            <a:off x="0" y="0"/>
+            <a:ext cx="6858000" cy="6858000"/>
+          </a:xfrm>
+          <a:prstGeom prst="rect">
+            <a:avLst/>
+          </a:prstGeom>
+        </p:spPr>
+      </p:pic>
+      <p:sp>
+        <p:nvSpPr>
+          <p:cNvPr id="2" name="Title 1">
+            <a:extLst>
+              <a:ext uri="{FF2B5EF4-FFF2-40B4-BE49-F238E27FC236}">
+                <a16:creationId xmlns:a16="http://schemas.microsoft.com/office/drawing/2014/main" id="{9AF452F5-0E64-C8A9-805B-D39DBC49B61C}"/>
+              </a:ext>
+            </a:extLst>
+          </p:cNvPr>
+          <p:cNvSpPr>
+            <a:spLocks noGrp="1"/>
+          </p:cNvSpPr>
+          <p:nvPr>
+            <p:ph type="ctrTitle"/>
+          </p:nvPr>
+        </p:nvSpPr>
+        <p:spPr/>
+        <p:txBody>
+          <a:bodyPr>
+            <a:noAutofit/>
+          </a:bodyPr>
+          <a:lstStyle/>
+          <a:p>
+            <a:r>
+              <a:rPr lang="en-US" sz="7200" dirty="0"/>
+              <a:t>Lumos</a:t>
+            </a:r>
+          </a:p>
+        </p:txBody>
+      </p:sp>
+      <p:sp>
+        <p:nvSpPr>
+          <p:cNvPr id="7" name="Text Placeholder 6">
+            <a:extLst>
+              <a:ext uri="{FF2B5EF4-FFF2-40B4-BE49-F238E27FC236}">
+                <a16:creationId xmlns:a16="http://schemas.microsoft.com/office/drawing/2014/main" id="{F738C757-42D6-9807-E8A2-F4B4BA7997A5}"/>
+              </a:ext>
+            </a:extLst>
+          </p:cNvPr>
+          <p:cNvSpPr>
+            <a:spLocks noGrp="1"/>
+          </p:cNvSpPr>
+          <p:nvPr>
+            <p:ph type="body" sz="quarter" idx="13"/>
+          </p:nvPr>
+        </p:nvSpPr>
+        <p:spPr/>
+        <p:txBody>
+          <a:bodyPr>
+            <a:normAutofit/>
+          </a:bodyPr>
+          <a:lstStyle/>
+          <a:p>
+            <a:r>
+              <a:rPr lang="en-US" dirty="0"/>
+              <a:t>What Zenith AS is missing?</a:t>
+            </a:r>
+          </a:p>
+        </p:txBody>
+      </p:sp>
+      <p:sp>
+        <p:nvSpPr>
+          <p:cNvPr id="8" name="Slide Number Placeholder 7">
+            <a:extLst>
+              <a:ext uri="{FF2B5EF4-FFF2-40B4-BE49-F238E27FC236}">
+                <a16:creationId xmlns:a16="http://schemas.microsoft.com/office/drawing/2014/main" id="{7E6BB04D-12CA-FC2A-C8C1-5E926640D31E}"/>
+              </a:ext>
+            </a:extLst>
+          </p:cNvPr>
+          <p:cNvSpPr>
+            <a:spLocks noGrp="1"/>
+          </p:cNvSpPr>
+          <p:nvPr>
+            <p:ph type="sldNum" sz="quarter" idx="4294967295"/>
+          </p:nvPr>
+        </p:nvSpPr>
+        <p:spPr>
+          <a:xfrm>
+            <a:off x="10708715" y="6356350"/>
+            <a:ext cx="524479" cy="365125"/>
+          </a:xfrm>
+          <a:prstGeom prst="rect">
+            <a:avLst/>
+          </a:prstGeom>
+        </p:spPr>
+        <p:txBody>
+          <a:bodyPr/>
+          <a:lstStyle/>
+          <a:p>
+            <a:fld id="{777B4535-3FCB-194B-8628-80D28B32D103}" type="slidenum">
+              <a:rPr lang="en-US" smtClean="0"/>
+              <a:t>2</a:t>
+            </a:fld>
+            <a:endParaRPr lang="en-US"/>
+          </a:p>
+        </p:txBody>
+      </p:sp>
+      <p:pic>
+        <p:nvPicPr>
+          <p:cNvPr id="11" name="Picture 10" descr="A white logo on a black background&#10;&#10;AI-generated content may be incorrect.">
+            <a:extLst>
+              <a:ext uri="{FF2B5EF4-FFF2-40B4-BE49-F238E27FC236}">
+                <a16:creationId xmlns:a16="http://schemas.microsoft.com/office/drawing/2014/main" id="{F4B36CB3-2A01-82EC-5038-ABA8CDD9A44F}"/>
+              </a:ext>
+            </a:extLst>
+          </p:cNvPr>
+          <p:cNvPicPr>
+            <a:picLocks noChangeAspect="1"/>
+          </p:cNvPicPr>
+          <p:nvPr/>
+        </p:nvPicPr>
+        <p:blipFill>
+          <a:blip r:embed="rId3"/>
+          <a:stretch>
+            <a:fillRect/>
+          </a:stretch>
+        </p:blipFill>
+        <p:spPr>
+          <a:xfrm>
+            <a:off x="9986962" y="0"/>
+            <a:ext cx="2379427" cy="1043141"/>
+          </a:xfrm>
+          <a:prstGeom prst="rect">
+            <a:avLst/>
+          </a:prstGeom>
+        </p:spPr>
+      </p:pic>
+      <p:sp>
+        <p:nvSpPr>
+          <p:cNvPr id="3" name="Subtitle 2">
+            <a:extLst>
+              <a:ext uri="{FF2B5EF4-FFF2-40B4-BE49-F238E27FC236}">
+                <a16:creationId xmlns:a16="http://schemas.microsoft.com/office/drawing/2014/main" id="{FFB68345-5CC1-23E9-2518-921583E644C3}"/>
+              </a:ext>
+            </a:extLst>
+          </p:cNvPr>
+          <p:cNvSpPr>
+            <a:spLocks noGrp="1"/>
+          </p:cNvSpPr>
+          <p:nvPr>
+            <p:ph type="subTitle" idx="1" hasCustomPrompt="1"/>
+          </p:nvPr>
+        </p:nvSpPr>
+        <p:spPr>
+          <a:xfrm>
+            <a:off x="154112" y="3429000"/>
+            <a:ext cx="9144000" cy="588196"/>
+          </a:xfrm>
+        </p:spPr>
+        <p:txBody>
+          <a:bodyPr/>
+          <a:lstStyle>
+            <a:lvl1pPr marL="0" indent="0" algn="l">
+              <a:buNone/>
+              <a:defRPr sz="2400">
+                <a:solidFill>
+                  <a:schemeClr val="accent1">
+                    <a:lumMod val="20000"/>
+                    <a:lumOff val="80000"/>
+                  </a:schemeClr>
+                </a:solidFill>
+              </a:defRPr>
+            </a:lvl1pPr>
+            <a:lvl2pPr marL="457200" indent="0" algn="ctr">
+              <a:buNone/>
+              <a:defRPr sz="2000"/>
+            </a:lvl2pPr>
+            <a:lvl3pPr marL="914400" indent="0" algn="ctr">
+              <a:buNone/>
+              <a:defRPr sz="1800"/>
+            </a:lvl3pPr>
+            <a:lvl4pPr marL="1371600" indent="0" algn="ctr">
+              <a:buNone/>
+              <a:defRPr sz="1600"/>
+            </a:lvl4pPr>
+            <a:lvl5pPr marL="1828800" indent="0" algn="ctr">
+              <a:buNone/>
+              <a:defRPr sz="1600"/>
+            </a:lvl5pPr>
+            <a:lvl6pPr marL="2286000" indent="0" algn="ctr">
+              <a:buNone/>
+              <a:defRPr sz="1600"/>
+            </a:lvl6pPr>
+            <a:lvl7pPr marL="2743200" indent="0" algn="ctr">
+              <a:buNone/>
+              <a:defRPr sz="1600"/>
+            </a:lvl7pPr>
+            <a:lvl8pPr marL="3200400" indent="0" algn="ctr">
+              <a:buNone/>
+              <a:defRPr sz="1600"/>
+            </a:lvl8pPr>
+            <a:lvl9pPr marL="3657600" indent="0" algn="ctr">
+              <a:buNone/>
+              <a:defRPr sz="1600"/>
+            </a:lvl9pPr>
+          </a:lstStyle>
+          <a:p>
+            <a:endParaRPr lang="en-US" dirty="0"/>
+          </a:p>
+        </p:txBody>
+      </p:sp>
+    </p:spTree>
+    <p:extLst>
+      <p:ext uri="{BB962C8B-B14F-4D97-AF65-F5344CB8AC3E}">
+        <p14:creationId xmlns:p14="http://schemas.microsoft.com/office/powerpoint/2010/main" val="3510596525"/>
+      </p:ext>
+    </p:extLst>
+  </p:cSld>
+  <p:clrMapOvr>
+    <a:masterClrMapping/>
+  </p:clrMapOvr>
+</p:sld>
+</file>
+
+<file path=ppt/slides/slide3.xml><?xml version="1.0" encoding="utf-8"?>
+<p:sld xmlns:a="http://schemas.openxmlformats.org/drawingml/2006/main" xmlns:r="http://schemas.openxmlformats.org/officeDocument/2006/relationships" xmlns:p="http://schemas.openxmlformats.org/presentationml/2006/main">
+  <p:cSld>
+    <p:spTree>
+      <p:nvGrpSpPr>
+        <p:cNvPr id="1" name="">
+          <a:extLst>
+            <a:ext uri="{FF2B5EF4-FFF2-40B4-BE49-F238E27FC236}">
+              <a16:creationId xmlns:a16="http://schemas.microsoft.com/office/drawing/2014/main" id="{63F90E8C-9744-5051-F12B-6DB4AAC148E4}"/>
+            </a:ext>
+          </a:extLst>
+        </p:cNvPr>
+        <p:cNvGrpSpPr/>
+        <p:nvPr/>
+      </p:nvGrpSpPr>
+      <p:grpSpPr>
+        <a:xfrm>
+          <a:off x="0" y="0"/>
+          <a:ext cx="0" cy="0"/>
+          <a:chOff x="0" y="0"/>
+          <a:chExt cx="0" cy="0"/>
+        </a:xfrm>
+      </p:grpSpPr>
+      <p:pic>
+        <p:nvPicPr>
+          <p:cNvPr id="16" name="Picture 15" descr="A black background with pink dots&#10;&#10;AI-generated content may be incorrect.">
+            <a:extLst>
+              <a:ext uri="{FF2B5EF4-FFF2-40B4-BE49-F238E27FC236}">
+                <a16:creationId xmlns:a16="http://schemas.microsoft.com/office/drawing/2014/main" id="{23A9FD63-DB4C-B6B6-0FF9-F804C1CD8683}"/>
+              </a:ext>
+            </a:extLst>
+          </p:cNvPr>
+          <p:cNvPicPr>
+            <a:picLocks noChangeAspect="1"/>
+          </p:cNvPicPr>
+          <p:nvPr/>
+        </p:nvPicPr>
+        <p:blipFill>
+          <a:blip r:embed="rId2"/>
+          <a:stretch>
+            <a:fillRect/>
+          </a:stretch>
+        </p:blipFill>
+        <p:spPr>
+          <a:xfrm>
+            <a:off x="6096000" y="0"/>
+            <a:ext cx="6858000" cy="6858000"/>
+          </a:xfrm>
+          <a:prstGeom prst="rect">
+            <a:avLst/>
+          </a:prstGeom>
+        </p:spPr>
+      </p:pic>
+      <p:pic>
+        <p:nvPicPr>
+          <p:cNvPr id="15" name="Picture 14" descr="A black background with pink dots&#10;&#10;AI-generated content may be incorrect.">
+            <a:extLst>
+              <a:ext uri="{FF2B5EF4-FFF2-40B4-BE49-F238E27FC236}">
+                <a16:creationId xmlns:a16="http://schemas.microsoft.com/office/drawing/2014/main" id="{41B8CE7E-5186-B8A0-F627-7CE437FD1FFA}"/>
+              </a:ext>
+            </a:extLst>
+          </p:cNvPr>
+          <p:cNvPicPr>
+            <a:picLocks noChangeAspect="1"/>
+          </p:cNvPicPr>
+          <p:nvPr/>
+        </p:nvPicPr>
+        <p:blipFill>
+          <a:blip r:embed="rId2"/>
+          <a:stretch>
+            <a:fillRect/>
+          </a:stretch>
+        </p:blipFill>
+        <p:spPr>
+          <a:xfrm>
+            <a:off x="0" y="0"/>
+            <a:ext cx="6858000" cy="6858000"/>
+          </a:xfrm>
+          <a:prstGeom prst="rect">
+            <a:avLst/>
+          </a:prstGeom>
+        </p:spPr>
+      </p:pic>
+      <p:sp>
+        <p:nvSpPr>
+          <p:cNvPr id="2" name="Title 1">
+            <a:extLst>
+              <a:ext uri="{FF2B5EF4-FFF2-40B4-BE49-F238E27FC236}">
+                <a16:creationId xmlns:a16="http://schemas.microsoft.com/office/drawing/2014/main" id="{9C537F69-7E73-1D28-8A68-7720023F36CF}"/>
+              </a:ext>
+            </a:extLst>
+          </p:cNvPr>
+          <p:cNvSpPr>
+            <a:spLocks noGrp="1"/>
+          </p:cNvSpPr>
+          <p:nvPr>
+            <p:ph type="ctrTitle"/>
+          </p:nvPr>
+        </p:nvSpPr>
+        <p:spPr/>
+        <p:txBody>
+          <a:bodyPr>
+            <a:noAutofit/>
+          </a:bodyPr>
+          <a:lstStyle/>
+          <a:p>
+            <a:r>
+              <a:rPr lang="en-US" sz="7200" dirty="0"/>
+              <a:t>Lumos</a:t>
+            </a:r>
+          </a:p>
+        </p:txBody>
+      </p:sp>
+      <p:sp>
+        <p:nvSpPr>
+          <p:cNvPr id="7" name="Text Placeholder 6">
+            <a:extLst>
+              <a:ext uri="{FF2B5EF4-FFF2-40B4-BE49-F238E27FC236}">
+                <a16:creationId xmlns:a16="http://schemas.microsoft.com/office/drawing/2014/main" id="{7F4C621E-8E0A-33FD-6F8A-7A20B651F1A3}"/>
+              </a:ext>
+            </a:extLst>
+          </p:cNvPr>
+          <p:cNvSpPr>
+            <a:spLocks noGrp="1"/>
+          </p:cNvSpPr>
+          <p:nvPr>
+            <p:ph type="body" sz="quarter" idx="13"/>
+          </p:nvPr>
+        </p:nvSpPr>
+        <p:spPr/>
+        <p:txBody>
+          <a:bodyPr>
+            <a:normAutofit fontScale="77500" lnSpcReduction="20000"/>
+          </a:bodyPr>
+          <a:lstStyle/>
+          <a:p>
+            <a:r>
+              <a:rPr lang="en-US" dirty="0"/>
+              <a:t>Assessment Center Presentation Template</a:t>
+            </a:r>
+          </a:p>
+        </p:txBody>
+      </p:sp>
+      <p:sp>
+        <p:nvSpPr>
+          <p:cNvPr id="8" name="Slide Number Placeholder 7">
+            <a:extLst>
+              <a:ext uri="{FF2B5EF4-FFF2-40B4-BE49-F238E27FC236}">
+                <a16:creationId xmlns:a16="http://schemas.microsoft.com/office/drawing/2014/main" id="{AECF5868-DD1F-A8F3-5BC5-2460E8B60AB6}"/>
+              </a:ext>
+            </a:extLst>
+          </p:cNvPr>
+          <p:cNvSpPr>
+            <a:spLocks noGrp="1"/>
+          </p:cNvSpPr>
+          <p:nvPr>
+            <p:ph type="sldNum" sz="quarter" idx="4294967295"/>
+          </p:nvPr>
+        </p:nvSpPr>
+        <p:spPr>
+          <a:xfrm>
+            <a:off x="10708715" y="6356350"/>
+            <a:ext cx="524479" cy="365125"/>
+          </a:xfrm>
+          <a:prstGeom prst="rect">
+            <a:avLst/>
+          </a:prstGeom>
+        </p:spPr>
+        <p:txBody>
+          <a:bodyPr/>
+          <a:lstStyle/>
+          <a:p>
+            <a:fld id="{777B4535-3FCB-194B-8628-80D28B32D103}" type="slidenum">
+              <a:rPr lang="en-US" smtClean="0"/>
+              <a:t>3</a:t>
+            </a:fld>
+            <a:endParaRPr lang="en-US"/>
+          </a:p>
+        </p:txBody>
+      </p:sp>
+      <p:pic>
+        <p:nvPicPr>
+          <p:cNvPr id="11" name="Picture 10" descr="A white logo on a black background&#10;&#10;AI-generated content may be incorrect.">
+            <a:extLst>
+              <a:ext uri="{FF2B5EF4-FFF2-40B4-BE49-F238E27FC236}">
+                <a16:creationId xmlns:a16="http://schemas.microsoft.com/office/drawing/2014/main" id="{CF6289C9-B6BA-4E77-5BC9-16C1B78DDE47}"/>
+              </a:ext>
+            </a:extLst>
+          </p:cNvPr>
+          <p:cNvPicPr>
+            <a:picLocks noChangeAspect="1"/>
+          </p:cNvPicPr>
+          <p:nvPr/>
+        </p:nvPicPr>
+        <p:blipFill>
+          <a:blip r:embed="rId3"/>
+          <a:stretch>
+            <a:fillRect/>
+          </a:stretch>
+        </p:blipFill>
+        <p:spPr>
+          <a:xfrm>
+            <a:off x="9986962" y="0"/>
+            <a:ext cx="2379427" cy="1043141"/>
+          </a:xfrm>
+          <a:prstGeom prst="rect">
+            <a:avLst/>
+          </a:prstGeom>
+        </p:spPr>
+      </p:pic>
+      <p:sp>
+        <p:nvSpPr>
+          <p:cNvPr id="3" name="Subtitle 2">
+            <a:extLst>
+              <a:ext uri="{FF2B5EF4-FFF2-40B4-BE49-F238E27FC236}">
+                <a16:creationId xmlns:a16="http://schemas.microsoft.com/office/drawing/2014/main" id="{46A4E99D-8B1A-54F7-92F0-DC1392295F87}"/>
+              </a:ext>
+            </a:extLst>
+          </p:cNvPr>
+          <p:cNvSpPr>
+            <a:spLocks noGrp="1"/>
+          </p:cNvSpPr>
+          <p:nvPr>
+            <p:ph type="subTitle" idx="1" hasCustomPrompt="1"/>
+          </p:nvPr>
+        </p:nvSpPr>
+        <p:spPr>
+          <a:xfrm>
+            <a:off x="154112" y="3429000"/>
+            <a:ext cx="9144000" cy="588196"/>
+          </a:xfrm>
+        </p:spPr>
+        <p:txBody>
+          <a:bodyPr/>
+          <a:lstStyle>
+            <a:lvl1pPr marL="0" indent="0" algn="l">
+              <a:buNone/>
+              <a:defRPr sz="2400">
+                <a:solidFill>
+                  <a:schemeClr val="accent1">
+                    <a:lumMod val="20000"/>
+                    <a:lumOff val="80000"/>
+                  </a:schemeClr>
+                </a:solidFill>
+              </a:defRPr>
+            </a:lvl1pPr>
+            <a:lvl2pPr marL="457200" indent="0" algn="ctr">
+              <a:buNone/>
+              <a:defRPr sz="2000"/>
+            </a:lvl2pPr>
+            <a:lvl3pPr marL="914400" indent="0" algn="ctr">
+              <a:buNone/>
+              <a:defRPr sz="1800"/>
+            </a:lvl3pPr>
+            <a:lvl4pPr marL="1371600" indent="0" algn="ctr">
+              <a:buNone/>
+              <a:defRPr sz="1600"/>
+            </a:lvl4pPr>
+            <a:lvl5pPr marL="1828800" indent="0" algn="ctr">
+              <a:buNone/>
+              <a:defRPr sz="1600"/>
+            </a:lvl5pPr>
+            <a:lvl6pPr marL="2286000" indent="0" algn="ctr">
+              <a:buNone/>
+              <a:defRPr sz="1600"/>
+            </a:lvl6pPr>
+            <a:lvl7pPr marL="2743200" indent="0" algn="ctr">
+              <a:buNone/>
+              <a:defRPr sz="1600"/>
+            </a:lvl7pPr>
+            <a:lvl8pPr marL="3200400" indent="0" algn="ctr">
+              <a:buNone/>
+              <a:defRPr sz="1600"/>
+            </a:lvl8pPr>
+            <a:lvl9pPr marL="3657600" indent="0" algn="ctr">
+              <a:buNone/>
+              <a:defRPr sz="1600"/>
+            </a:lvl9pPr>
+          </a:lstStyle>
+          <a:p>
+            <a:r>
+              <a:rPr lang="en-US" dirty="0"/>
+              <a:t>Zenith</a:t>
+            </a:r>
+          </a:p>
+        </p:txBody>
+      </p:sp>
+    </p:spTree>
+    <p:extLst>
+      <p:ext uri="{BB962C8B-B14F-4D97-AF65-F5344CB8AC3E}">
+        <p14:creationId xmlns:p14="http://schemas.microsoft.com/office/powerpoint/2010/main" val="2686662956"/>
+      </p:ext>
+    </p:extLst>
+  </p:cSld>
+  <p:clrMapOvr>
+    <a:masterClrMapping/>
+  </p:clrMapOvr>
+</p:sld>
+</file>
+
+<file path=ppt/slides/slide4.xml><?xml version="1.0" encoding="utf-8"?>
+<p:sld xmlns:a="http://schemas.openxmlformats.org/drawingml/2006/main" xmlns:r="http://schemas.openxmlformats.org/officeDocument/2006/relationships" xmlns:p="http://schemas.openxmlformats.org/presentationml/2006/main">
+  <p:cSld>
+    <p:spTree>
+      <p:nvGrpSpPr>
+        <p:cNvPr id="1" name="">
+          <a:extLst>
+            <a:ext uri="{FF2B5EF4-FFF2-40B4-BE49-F238E27FC236}">
+              <a16:creationId xmlns:a16="http://schemas.microsoft.com/office/drawing/2014/main" id="{B5D7FB35-CD3E-2856-C64C-5D3E4890B9CA}"/>
+            </a:ext>
+          </a:extLst>
+        </p:cNvPr>
+        <p:cNvGrpSpPr/>
+        <p:nvPr/>
+      </p:nvGrpSpPr>
+      <p:grpSpPr>
+        <a:xfrm>
+          <a:off x="0" y="0"/>
+          <a:ext cx="0" cy="0"/>
+          <a:chOff x="0" y="0"/>
+          <a:chExt cx="0" cy="0"/>
+        </a:xfrm>
+      </p:grpSpPr>
+      <p:pic>
+        <p:nvPicPr>
+          <p:cNvPr id="16" name="Picture 15" descr="A black background with pink dots&#10;&#10;AI-generated content may be incorrect.">
+            <a:extLst>
+              <a:ext uri="{FF2B5EF4-FFF2-40B4-BE49-F238E27FC236}">
+                <a16:creationId xmlns:a16="http://schemas.microsoft.com/office/drawing/2014/main" id="{3FC4BDEC-312B-DFA8-1EC3-A9A8C93F26E9}"/>
+              </a:ext>
+            </a:extLst>
+          </p:cNvPr>
+          <p:cNvPicPr>
+            <a:picLocks noChangeAspect="1"/>
+          </p:cNvPicPr>
+          <p:nvPr/>
+        </p:nvPicPr>
+        <p:blipFill>
+          <a:blip r:embed="rId2"/>
+          <a:stretch>
+            <a:fillRect/>
+          </a:stretch>
+        </p:blipFill>
+        <p:spPr>
+          <a:xfrm>
+            <a:off x="6096000" y="0"/>
+            <a:ext cx="6858000" cy="6858000"/>
+          </a:xfrm>
+          <a:prstGeom prst="rect">
+            <a:avLst/>
+          </a:prstGeom>
+        </p:spPr>
+      </p:pic>
+      <p:pic>
+        <p:nvPicPr>
+          <p:cNvPr id="15" name="Picture 14" descr="A black background with pink dots&#10;&#10;AI-generated content may be incorrect.">
+            <a:extLst>
+              <a:ext uri="{FF2B5EF4-FFF2-40B4-BE49-F238E27FC236}">
+                <a16:creationId xmlns:a16="http://schemas.microsoft.com/office/drawing/2014/main" id="{B54F89BF-9449-9799-A66B-AA5A183057D0}"/>
+              </a:ext>
+            </a:extLst>
+          </p:cNvPr>
+          <p:cNvPicPr>
+            <a:picLocks noChangeAspect="1"/>
+          </p:cNvPicPr>
+          <p:nvPr/>
+        </p:nvPicPr>
+        <p:blipFill>
+          <a:blip r:embed="rId2"/>
+          <a:stretch>
+            <a:fillRect/>
+          </a:stretch>
+        </p:blipFill>
+        <p:spPr>
+          <a:xfrm>
+            <a:off x="0" y="0"/>
+            <a:ext cx="6858000" cy="6858000"/>
+          </a:xfrm>
+          <a:prstGeom prst="rect">
+            <a:avLst/>
+          </a:prstGeom>
+        </p:spPr>
+      </p:pic>
+      <p:sp>
+        <p:nvSpPr>
+          <p:cNvPr id="2" name="Title 1">
+            <a:extLst>
+              <a:ext uri="{FF2B5EF4-FFF2-40B4-BE49-F238E27FC236}">
+                <a16:creationId xmlns:a16="http://schemas.microsoft.com/office/drawing/2014/main" id="{316A18CD-2941-73FD-7861-B5DC993DE654}"/>
+              </a:ext>
+            </a:extLst>
+          </p:cNvPr>
+          <p:cNvSpPr>
+            <a:spLocks noGrp="1"/>
+          </p:cNvSpPr>
+          <p:nvPr>
+            <p:ph type="ctrTitle"/>
+          </p:nvPr>
+        </p:nvSpPr>
+        <p:spPr/>
+        <p:txBody>
+          <a:bodyPr>
+            <a:noAutofit/>
+          </a:bodyPr>
+          <a:lstStyle/>
+          <a:p>
+            <a:r>
+              <a:rPr lang="en-US" sz="7200" dirty="0"/>
+              <a:t>Lumos</a:t>
+            </a:r>
+          </a:p>
+        </p:txBody>
+      </p:sp>
+      <p:sp>
+        <p:nvSpPr>
+          <p:cNvPr id="7" name="Text Placeholder 6">
+            <a:extLst>
+              <a:ext uri="{FF2B5EF4-FFF2-40B4-BE49-F238E27FC236}">
+                <a16:creationId xmlns:a16="http://schemas.microsoft.com/office/drawing/2014/main" id="{822CC869-7AD9-B0EC-092A-A88F87B4FDD1}"/>
+              </a:ext>
+            </a:extLst>
+          </p:cNvPr>
+          <p:cNvSpPr>
+            <a:spLocks noGrp="1"/>
+          </p:cNvSpPr>
+          <p:nvPr>
+            <p:ph type="body" sz="quarter" idx="13"/>
+          </p:nvPr>
+        </p:nvSpPr>
+        <p:spPr/>
+        <p:txBody>
+          <a:bodyPr>
+            <a:normAutofit/>
+          </a:bodyPr>
+          <a:lstStyle/>
+          <a:p>
+            <a:r>
+              <a:rPr lang="en-US" dirty="0"/>
+              <a:t>Data Analysis and Findings</a:t>
+            </a:r>
+          </a:p>
+        </p:txBody>
+      </p:sp>
+      <p:sp>
+        <p:nvSpPr>
+          <p:cNvPr id="8" name="Slide Number Placeholder 7">
+            <a:extLst>
+              <a:ext uri="{FF2B5EF4-FFF2-40B4-BE49-F238E27FC236}">
+                <a16:creationId xmlns:a16="http://schemas.microsoft.com/office/drawing/2014/main" id="{88B618E2-D08F-8EFD-2C79-FB0F0B97BDF3}"/>
+              </a:ext>
+            </a:extLst>
+          </p:cNvPr>
+          <p:cNvSpPr>
+            <a:spLocks noGrp="1"/>
+          </p:cNvSpPr>
+          <p:nvPr>
+            <p:ph type="sldNum" sz="quarter" idx="4294967295"/>
+          </p:nvPr>
+        </p:nvSpPr>
+        <p:spPr>
+          <a:xfrm>
+            <a:off x="10708715" y="6356350"/>
+            <a:ext cx="524479" cy="365125"/>
+          </a:xfrm>
+          <a:prstGeom prst="rect">
+            <a:avLst/>
+          </a:prstGeom>
+        </p:spPr>
+        <p:txBody>
+          <a:bodyPr/>
+          <a:lstStyle/>
+          <a:p>
+            <a:fld id="{777B4535-3FCB-194B-8628-80D28B32D103}" type="slidenum">
+              <a:rPr lang="en-US" smtClean="0"/>
+              <a:t>4</a:t>
+            </a:fld>
+            <a:endParaRPr lang="en-US"/>
+          </a:p>
+        </p:txBody>
+      </p:sp>
+      <p:pic>
+        <p:nvPicPr>
+          <p:cNvPr id="11" name="Picture 10" descr="A white logo on a black background&#10;&#10;AI-generated content may be incorrect.">
+            <a:extLst>
+              <a:ext uri="{FF2B5EF4-FFF2-40B4-BE49-F238E27FC236}">
+                <a16:creationId xmlns:a16="http://schemas.microsoft.com/office/drawing/2014/main" id="{7F80AB7E-79F9-DECB-4198-67EE9327DE5D}"/>
+              </a:ext>
+            </a:extLst>
+          </p:cNvPr>
+          <p:cNvPicPr>
+            <a:picLocks noChangeAspect="1"/>
+          </p:cNvPicPr>
+          <p:nvPr/>
+        </p:nvPicPr>
+        <p:blipFill>
+          <a:blip r:embed="rId3"/>
+          <a:stretch>
+            <a:fillRect/>
+          </a:stretch>
+        </p:blipFill>
+        <p:spPr>
+          <a:xfrm>
+            <a:off x="9986962" y="0"/>
+            <a:ext cx="2379427" cy="1043141"/>
+          </a:xfrm>
+          <a:prstGeom prst="rect">
+            <a:avLst/>
+          </a:prstGeom>
+        </p:spPr>
+      </p:pic>
+      <p:sp>
+        <p:nvSpPr>
+          <p:cNvPr id="3" name="Subtitle 2">
+            <a:extLst>
+              <a:ext uri="{FF2B5EF4-FFF2-40B4-BE49-F238E27FC236}">
+                <a16:creationId xmlns:a16="http://schemas.microsoft.com/office/drawing/2014/main" id="{422FE383-0E2E-F48E-4DD8-4187837406D3}"/>
+              </a:ext>
+            </a:extLst>
+          </p:cNvPr>
+          <p:cNvSpPr>
+            <a:spLocks noGrp="1"/>
+          </p:cNvSpPr>
+          <p:nvPr>
+            <p:ph type="subTitle" idx="1" hasCustomPrompt="1"/>
+          </p:nvPr>
+        </p:nvSpPr>
+        <p:spPr>
+          <a:xfrm>
+            <a:off x="154112" y="3429000"/>
+            <a:ext cx="9144000" cy="588196"/>
+          </a:xfrm>
+        </p:spPr>
+        <p:txBody>
+          <a:bodyPr/>
+          <a:lstStyle>
+            <a:lvl1pPr marL="0" indent="0" algn="l">
+              <a:buNone/>
+              <a:defRPr sz="2400">
+                <a:solidFill>
+                  <a:schemeClr val="accent1">
+                    <a:lumMod val="20000"/>
+                    <a:lumOff val="80000"/>
+                  </a:schemeClr>
+                </a:solidFill>
+              </a:defRPr>
+            </a:lvl1pPr>
+            <a:lvl2pPr marL="457200" indent="0" algn="ctr">
+              <a:buNone/>
+              <a:defRPr sz="2000"/>
+            </a:lvl2pPr>
+            <a:lvl3pPr marL="914400" indent="0" algn="ctr">
+              <a:buNone/>
+              <a:defRPr sz="1800"/>
+            </a:lvl3pPr>
+            <a:lvl4pPr marL="1371600" indent="0" algn="ctr">
+              <a:buNone/>
+              <a:defRPr sz="1600"/>
+            </a:lvl4pPr>
+            <a:lvl5pPr marL="1828800" indent="0" algn="ctr">
+              <a:buNone/>
+              <a:defRPr sz="1600"/>
+            </a:lvl5pPr>
+            <a:lvl6pPr marL="2286000" indent="0" algn="ctr">
+              <a:buNone/>
+              <a:defRPr sz="1600"/>
+            </a:lvl6pPr>
+            <a:lvl7pPr marL="2743200" indent="0" algn="ctr">
+              <a:buNone/>
+              <a:defRPr sz="1600"/>
+            </a:lvl7pPr>
+            <a:lvl8pPr marL="3200400" indent="0" algn="ctr">
+              <a:buNone/>
+              <a:defRPr sz="1600"/>
+            </a:lvl8pPr>
+            <a:lvl9pPr marL="3657600" indent="0" algn="ctr">
+              <a:buNone/>
+              <a:defRPr sz="1600"/>
+            </a:lvl9pPr>
+          </a:lstStyle>
+          <a:p>
+            <a:r>
+              <a:rPr lang="en-US" dirty="0"/>
+              <a:t>Zenith</a:t>
+            </a:r>
+          </a:p>
+        </p:txBody>
+      </p:sp>
+    </p:spTree>
+    <p:extLst>
+      <p:ext uri="{BB962C8B-B14F-4D97-AF65-F5344CB8AC3E}">
+        <p14:creationId xmlns:p14="http://schemas.microsoft.com/office/powerpoint/2010/main" val="2600279700"/>
+      </p:ext>
+    </p:extLst>
+  </p:cSld>
+  <p:clrMapOvr>
+    <a:masterClrMapping/>
+  </p:clrMapOvr>
+</p:sld>
+</file>
+
+<file path=ppt/slides/slide5.xml><?xml version="1.0" encoding="utf-8"?>
+<p:sld xmlns:a="http://schemas.openxmlformats.org/drawingml/2006/main" xmlns:r="http://schemas.openxmlformats.org/officeDocument/2006/relationships" xmlns:p="http://schemas.openxmlformats.org/presentationml/2006/main">
+  <p:cSld>
+    <p:spTree>
+      <p:nvGrpSpPr>
+        <p:cNvPr id="1" name="">
+          <a:extLst>
+            <a:ext uri="{FF2B5EF4-FFF2-40B4-BE49-F238E27FC236}">
+              <a16:creationId xmlns:a16="http://schemas.microsoft.com/office/drawing/2014/main" id="{1697D357-F51F-4E16-A703-290D907EAE50}"/>
+            </a:ext>
+          </a:extLst>
+        </p:cNvPr>
+        <p:cNvGrpSpPr/>
+        <p:nvPr/>
+      </p:nvGrpSpPr>
+      <p:grpSpPr>
+        <a:xfrm>
+          <a:off x="0" y="0"/>
+          <a:ext cx="0" cy="0"/>
+          <a:chOff x="0" y="0"/>
+          <a:chExt cx="0" cy="0"/>
+        </a:xfrm>
+      </p:grpSpPr>
+      <p:pic>
+        <p:nvPicPr>
+          <p:cNvPr id="16" name="Picture 15" descr="A black background with pink dots&#10;&#10;AI-generated content may be incorrect.">
+            <a:extLst>
+              <a:ext uri="{FF2B5EF4-FFF2-40B4-BE49-F238E27FC236}">
+                <a16:creationId xmlns:a16="http://schemas.microsoft.com/office/drawing/2014/main" id="{B51CE34E-5BE5-83FD-AF91-005CBB2C4795}"/>
+              </a:ext>
+            </a:extLst>
+          </p:cNvPr>
+          <p:cNvPicPr>
+            <a:picLocks noChangeAspect="1"/>
+          </p:cNvPicPr>
+          <p:nvPr/>
+        </p:nvPicPr>
+        <p:blipFill>
+          <a:blip r:embed="rId2"/>
+          <a:stretch>
+            <a:fillRect/>
+          </a:stretch>
+        </p:blipFill>
+        <p:spPr>
+          <a:xfrm>
+            <a:off x="6096000" y="0"/>
+            <a:ext cx="6858000" cy="6858000"/>
+          </a:xfrm>
+          <a:prstGeom prst="rect">
+            <a:avLst/>
+          </a:prstGeom>
+        </p:spPr>
+      </p:pic>
+      <p:pic>
+        <p:nvPicPr>
+          <p:cNvPr id="15" name="Picture 14" descr="A black background with pink dots&#10;&#10;AI-generated content may be incorrect.">
+            <a:extLst>
+              <a:ext uri="{FF2B5EF4-FFF2-40B4-BE49-F238E27FC236}">
+                <a16:creationId xmlns:a16="http://schemas.microsoft.com/office/drawing/2014/main" id="{E9788D30-3E4F-16DF-6391-BE30B922D77A}"/>
+              </a:ext>
+            </a:extLst>
+          </p:cNvPr>
+          <p:cNvPicPr>
+            <a:picLocks noChangeAspect="1"/>
+          </p:cNvPicPr>
+          <p:nvPr/>
+        </p:nvPicPr>
+        <p:blipFill>
+          <a:blip r:embed="rId2"/>
+          <a:stretch>
+            <a:fillRect/>
+          </a:stretch>
+        </p:blipFill>
+        <p:spPr>
+          <a:xfrm>
+            <a:off x="0" y="0"/>
+            <a:ext cx="6858000" cy="6858000"/>
+          </a:xfrm>
+          <a:prstGeom prst="rect">
+            <a:avLst/>
+          </a:prstGeom>
+        </p:spPr>
+      </p:pic>
+      <p:sp>
+        <p:nvSpPr>
+          <p:cNvPr id="2" name="Title 1">
+            <a:extLst>
+              <a:ext uri="{FF2B5EF4-FFF2-40B4-BE49-F238E27FC236}">
+                <a16:creationId xmlns:a16="http://schemas.microsoft.com/office/drawing/2014/main" id="{323A079F-A502-3EFB-7C9B-DB3D031ED319}"/>
+              </a:ext>
+            </a:extLst>
+          </p:cNvPr>
+          <p:cNvSpPr>
+            <a:spLocks noGrp="1"/>
+          </p:cNvSpPr>
+          <p:nvPr>
+            <p:ph type="ctrTitle"/>
+          </p:nvPr>
+        </p:nvSpPr>
+        <p:spPr/>
+        <p:txBody>
+          <a:bodyPr>
+            <a:noAutofit/>
+          </a:bodyPr>
+          <a:lstStyle/>
+          <a:p>
+            <a:r>
+              <a:rPr lang="en-US" sz="7200" dirty="0"/>
+              <a:t>Lumos</a:t>
+            </a:r>
+          </a:p>
+        </p:txBody>
+      </p:sp>
+      <p:sp>
+        <p:nvSpPr>
+          <p:cNvPr id="7" name="Text Placeholder 6">
+            <a:extLst>
+              <a:ext uri="{FF2B5EF4-FFF2-40B4-BE49-F238E27FC236}">
+                <a16:creationId xmlns:a16="http://schemas.microsoft.com/office/drawing/2014/main" id="{6F028EDB-C0BB-3FDE-5DF7-B563676F602B}"/>
+              </a:ext>
+            </a:extLst>
+          </p:cNvPr>
+          <p:cNvSpPr>
+            <a:spLocks noGrp="1"/>
+          </p:cNvSpPr>
+          <p:nvPr>
+            <p:ph type="body" sz="quarter" idx="13"/>
+          </p:nvPr>
+        </p:nvSpPr>
+        <p:spPr/>
+        <p:txBody>
+          <a:bodyPr>
+            <a:normAutofit fontScale="77500" lnSpcReduction="20000"/>
+          </a:bodyPr>
+          <a:lstStyle/>
+          <a:p>
+            <a:r>
+              <a:rPr lang="en-US" dirty="0"/>
+              <a:t>Assessment Center Presentation Template</a:t>
+            </a:r>
+          </a:p>
+        </p:txBody>
+      </p:sp>
+      <p:sp>
+        <p:nvSpPr>
+          <p:cNvPr id="8" name="Slide Number Placeholder 7">
+            <a:extLst>
+              <a:ext uri="{FF2B5EF4-FFF2-40B4-BE49-F238E27FC236}">
+                <a16:creationId xmlns:a16="http://schemas.microsoft.com/office/drawing/2014/main" id="{6EA9D55A-F9ED-FA09-5811-127EE2036A1E}"/>
+              </a:ext>
+            </a:extLst>
+          </p:cNvPr>
+          <p:cNvSpPr>
+            <a:spLocks noGrp="1"/>
+          </p:cNvSpPr>
+          <p:nvPr>
+            <p:ph type="sldNum" sz="quarter" idx="4294967295"/>
+          </p:nvPr>
+        </p:nvSpPr>
+        <p:spPr>
+          <a:xfrm>
+            <a:off x="10708715" y="6356350"/>
+            <a:ext cx="524479" cy="365125"/>
+          </a:xfrm>
+          <a:prstGeom prst="rect">
+            <a:avLst/>
+          </a:prstGeom>
+        </p:spPr>
+        <p:txBody>
+          <a:bodyPr/>
+          <a:lstStyle/>
+          <a:p>
+            <a:fld id="{777B4535-3FCB-194B-8628-80D28B32D103}" type="slidenum">
+              <a:rPr lang="en-US" smtClean="0"/>
+              <a:t>5</a:t>
+            </a:fld>
+            <a:endParaRPr lang="en-US"/>
+          </a:p>
+        </p:txBody>
+      </p:sp>
+      <p:pic>
+        <p:nvPicPr>
+          <p:cNvPr id="11" name="Picture 10" descr="A white logo on a black background&#10;&#10;AI-generated content may be incorrect.">
+            <a:extLst>
+              <a:ext uri="{FF2B5EF4-FFF2-40B4-BE49-F238E27FC236}">
+                <a16:creationId xmlns:a16="http://schemas.microsoft.com/office/drawing/2014/main" id="{D8A8FE2C-6B0B-FA39-8059-0F9D490A439F}"/>
+              </a:ext>
+            </a:extLst>
+          </p:cNvPr>
+          <p:cNvPicPr>
+            <a:picLocks noChangeAspect="1"/>
+          </p:cNvPicPr>
+          <p:nvPr/>
+        </p:nvPicPr>
+        <p:blipFill>
+          <a:blip r:embed="rId3"/>
+          <a:stretch>
+            <a:fillRect/>
+          </a:stretch>
+        </p:blipFill>
+        <p:spPr>
+          <a:xfrm>
+            <a:off x="9986962" y="0"/>
+            <a:ext cx="2379427" cy="1043141"/>
+          </a:xfrm>
+          <a:prstGeom prst="rect">
+            <a:avLst/>
+          </a:prstGeom>
+        </p:spPr>
+      </p:pic>
+      <p:sp>
+        <p:nvSpPr>
+          <p:cNvPr id="3" name="Subtitle 2">
+            <a:extLst>
+              <a:ext uri="{FF2B5EF4-FFF2-40B4-BE49-F238E27FC236}">
+                <a16:creationId xmlns:a16="http://schemas.microsoft.com/office/drawing/2014/main" id="{544177FF-82E4-54BD-6168-CA1014ED1411}"/>
+              </a:ext>
+            </a:extLst>
+          </p:cNvPr>
+          <p:cNvSpPr>
+            <a:spLocks noGrp="1"/>
+          </p:cNvSpPr>
+          <p:nvPr>
+            <p:ph type="subTitle" idx="1" hasCustomPrompt="1"/>
+          </p:nvPr>
+        </p:nvSpPr>
+        <p:spPr>
+          <a:xfrm>
+            <a:off x="154112" y="3429000"/>
+            <a:ext cx="9144000" cy="588196"/>
+          </a:xfrm>
+        </p:spPr>
+        <p:txBody>
+          <a:bodyPr/>
+          <a:lstStyle>
+            <a:lvl1pPr marL="0" indent="0" algn="l">
+              <a:buNone/>
+              <a:defRPr sz="2400">
+                <a:solidFill>
+                  <a:schemeClr val="accent1">
+                    <a:lumMod val="20000"/>
+                    <a:lumOff val="80000"/>
+                  </a:schemeClr>
+                </a:solidFill>
+              </a:defRPr>
+            </a:lvl1pPr>
+            <a:lvl2pPr marL="457200" indent="0" algn="ctr">
+              <a:buNone/>
+              <a:defRPr sz="2000"/>
+            </a:lvl2pPr>
+            <a:lvl3pPr marL="914400" indent="0" algn="ctr">
+              <a:buNone/>
+              <a:defRPr sz="1800"/>
+            </a:lvl3pPr>
+            <a:lvl4pPr marL="1371600" indent="0" algn="ctr">
+              <a:buNone/>
+              <a:defRPr sz="1600"/>
+            </a:lvl4pPr>
+            <a:lvl5pPr marL="1828800" indent="0" algn="ctr">
+              <a:buNone/>
+              <a:defRPr sz="1600"/>
+            </a:lvl5pPr>
+            <a:lvl6pPr marL="2286000" indent="0" algn="ctr">
+              <a:buNone/>
+              <a:defRPr sz="1600"/>
+            </a:lvl6pPr>
+            <a:lvl7pPr marL="2743200" indent="0" algn="ctr">
+              <a:buNone/>
+              <a:defRPr sz="1600"/>
+            </a:lvl7pPr>
+            <a:lvl8pPr marL="3200400" indent="0" algn="ctr">
+              <a:buNone/>
+              <a:defRPr sz="1600"/>
+            </a:lvl8pPr>
+            <a:lvl9pPr marL="3657600" indent="0" algn="ctr">
+              <a:buNone/>
+              <a:defRPr sz="1600"/>
+            </a:lvl9pPr>
+          </a:lstStyle>
+          <a:p>
+            <a:r>
+              <a:rPr lang="en-US" dirty="0"/>
+              <a:t>Zenith</a:t>
+            </a:r>
+          </a:p>
+        </p:txBody>
+      </p:sp>
+    </p:spTree>
+    <p:extLst>
+      <p:ext uri="{BB962C8B-B14F-4D97-AF65-F5344CB8AC3E}">
+        <p14:creationId xmlns:p14="http://schemas.microsoft.com/office/powerpoint/2010/main" val="581599528"/>
+      </p:ext>
+    </p:extLst>
+  </p:cSld>
+  <p:clrMapOvr>
+    <a:masterClrMapping/>
+  </p:clrMapOvr>
+</p:sld>
+</file>
+
+<file path=ppt/slides/slide6.xml><?xml version="1.0" encoding="utf-8"?>
+<p:sld xmlns:a="http://schemas.openxmlformats.org/drawingml/2006/main" xmlns:r="http://schemas.openxmlformats.org/officeDocument/2006/relationships" xmlns:p="http://schemas.openxmlformats.org/presentationml/2006/main">
+  <p:cSld>
+    <p:spTree>
+      <p:nvGrpSpPr>
+        <p:cNvPr id="1" name="">
+          <a:extLst>
+            <a:ext uri="{FF2B5EF4-FFF2-40B4-BE49-F238E27FC236}">
+              <a16:creationId xmlns:a16="http://schemas.microsoft.com/office/drawing/2014/main" id="{F8D107CF-4590-E991-AF16-82B7F8E22307}"/>
+            </a:ext>
+          </a:extLst>
+        </p:cNvPr>
+        <p:cNvGrpSpPr/>
+        <p:nvPr/>
+      </p:nvGrpSpPr>
+      <p:grpSpPr>
+        <a:xfrm>
+          <a:off x="0" y="0"/>
+          <a:ext cx="0" cy="0"/>
+          <a:chOff x="0" y="0"/>
+          <a:chExt cx="0" cy="0"/>
+        </a:xfrm>
+      </p:grpSpPr>
+      <p:pic>
+        <p:nvPicPr>
+          <p:cNvPr id="16" name="Picture 15" descr="A black background with pink dots&#10;&#10;AI-generated content may be incorrect.">
+            <a:extLst>
+              <a:ext uri="{FF2B5EF4-FFF2-40B4-BE49-F238E27FC236}">
+                <a16:creationId xmlns:a16="http://schemas.microsoft.com/office/drawing/2014/main" id="{5FB5C58C-CF67-640E-BC38-80E5E029AF38}"/>
+              </a:ext>
+            </a:extLst>
+          </p:cNvPr>
+          <p:cNvPicPr>
+            <a:picLocks noChangeAspect="1"/>
+          </p:cNvPicPr>
+          <p:nvPr/>
+        </p:nvPicPr>
+        <p:blipFill>
+          <a:blip r:embed="rId2"/>
+          <a:stretch>
+            <a:fillRect/>
+          </a:stretch>
+        </p:blipFill>
+        <p:spPr>
+          <a:xfrm>
+            <a:off x="6096000" y="0"/>
+            <a:ext cx="6858000" cy="6858000"/>
+          </a:xfrm>
+          <a:prstGeom prst="rect">
+            <a:avLst/>
+          </a:prstGeom>
+        </p:spPr>
+      </p:pic>
+      <p:pic>
+        <p:nvPicPr>
+          <p:cNvPr id="15" name="Picture 14" descr="A black background with pink dots&#10;&#10;AI-generated content may be incorrect.">
+            <a:extLst>
+              <a:ext uri="{FF2B5EF4-FFF2-40B4-BE49-F238E27FC236}">
+                <a16:creationId xmlns:a16="http://schemas.microsoft.com/office/drawing/2014/main" id="{3C28FF6D-FEE5-CF46-9FDD-4BAEDDB4F323}"/>
+              </a:ext>
+            </a:extLst>
+          </p:cNvPr>
+          <p:cNvPicPr>
+            <a:picLocks noChangeAspect="1"/>
+          </p:cNvPicPr>
+          <p:nvPr/>
+        </p:nvPicPr>
+        <p:blipFill>
+          <a:blip r:embed="rId2"/>
+          <a:stretch>
+            <a:fillRect/>
+          </a:stretch>
+        </p:blipFill>
+        <p:spPr>
+          <a:xfrm>
+            <a:off x="0" y="0"/>
+            <a:ext cx="6858000" cy="6858000"/>
+          </a:xfrm>
+          <a:prstGeom prst="rect">
+            <a:avLst/>
+          </a:prstGeom>
+        </p:spPr>
+      </p:pic>
+      <p:sp>
+        <p:nvSpPr>
+          <p:cNvPr id="2" name="Title 1">
+            <a:extLst>
+              <a:ext uri="{FF2B5EF4-FFF2-40B4-BE49-F238E27FC236}">
+                <a16:creationId xmlns:a16="http://schemas.microsoft.com/office/drawing/2014/main" id="{04C7BAB3-6396-2D40-3D82-AAD68C80E98F}"/>
+              </a:ext>
+            </a:extLst>
+          </p:cNvPr>
+          <p:cNvSpPr>
+            <a:spLocks noGrp="1"/>
+          </p:cNvSpPr>
+          <p:nvPr>
+            <p:ph type="ctrTitle"/>
+          </p:nvPr>
+        </p:nvSpPr>
+        <p:spPr/>
+        <p:txBody>
+          <a:bodyPr>
+            <a:noAutofit/>
+          </a:bodyPr>
+          <a:lstStyle/>
+          <a:p>
+            <a:r>
+              <a:rPr lang="en-US" sz="7200" dirty="0"/>
+              <a:t>Lumos</a:t>
+            </a:r>
+          </a:p>
+        </p:txBody>
+      </p:sp>
+      <p:sp>
+        <p:nvSpPr>
+          <p:cNvPr id="7" name="Text Placeholder 6">
+            <a:extLst>
+              <a:ext uri="{FF2B5EF4-FFF2-40B4-BE49-F238E27FC236}">
+                <a16:creationId xmlns:a16="http://schemas.microsoft.com/office/drawing/2014/main" id="{25E3442B-3059-4F99-46C7-5F6C0CED07CB}"/>
+              </a:ext>
+            </a:extLst>
+          </p:cNvPr>
+          <p:cNvSpPr>
+            <a:spLocks noGrp="1"/>
+          </p:cNvSpPr>
+          <p:nvPr>
+            <p:ph type="body" sz="quarter" idx="13"/>
+          </p:nvPr>
+        </p:nvSpPr>
+        <p:spPr/>
+        <p:txBody>
+          <a:bodyPr>
+            <a:normAutofit/>
+          </a:bodyPr>
+          <a:lstStyle/>
+          <a:p>
+            <a:r>
+              <a:rPr lang="en-US" dirty="0"/>
+              <a:t>Solutions</a:t>
+            </a:r>
+          </a:p>
+        </p:txBody>
+      </p:sp>
+      <p:sp>
+        <p:nvSpPr>
+          <p:cNvPr id="8" name="Slide Number Placeholder 7">
+            <a:extLst>
+              <a:ext uri="{FF2B5EF4-FFF2-40B4-BE49-F238E27FC236}">
+                <a16:creationId xmlns:a16="http://schemas.microsoft.com/office/drawing/2014/main" id="{D3D74CA6-D1EB-F02E-2C31-0502607173DF}"/>
+              </a:ext>
+            </a:extLst>
+          </p:cNvPr>
+          <p:cNvSpPr>
+            <a:spLocks noGrp="1"/>
+          </p:cNvSpPr>
+          <p:nvPr>
+            <p:ph type="sldNum" sz="quarter" idx="4294967295"/>
+          </p:nvPr>
+        </p:nvSpPr>
+        <p:spPr>
+          <a:xfrm>
+            <a:off x="10708715" y="6356350"/>
+            <a:ext cx="524479" cy="365125"/>
+          </a:xfrm>
+          <a:prstGeom prst="rect">
+            <a:avLst/>
+          </a:prstGeom>
+        </p:spPr>
+        <p:txBody>
+          <a:bodyPr/>
+          <a:lstStyle/>
+          <a:p>
+            <a:fld id="{777B4535-3FCB-194B-8628-80D28B32D103}" type="slidenum">
+              <a:rPr lang="en-US" smtClean="0"/>
+              <a:t>6</a:t>
+            </a:fld>
+            <a:endParaRPr lang="en-US"/>
+          </a:p>
+        </p:txBody>
+      </p:sp>
+      <p:pic>
+        <p:nvPicPr>
+          <p:cNvPr id="11" name="Picture 10" descr="A white logo on a black background&#10;&#10;AI-generated content may be incorrect.">
+            <a:extLst>
+              <a:ext uri="{FF2B5EF4-FFF2-40B4-BE49-F238E27FC236}">
+                <a16:creationId xmlns:a16="http://schemas.microsoft.com/office/drawing/2014/main" id="{7DA1BAFF-0958-4B9A-9693-0360F09EA3F3}"/>
+              </a:ext>
+            </a:extLst>
+          </p:cNvPr>
+          <p:cNvPicPr>
+            <a:picLocks noChangeAspect="1"/>
+          </p:cNvPicPr>
+          <p:nvPr/>
+        </p:nvPicPr>
+        <p:blipFill>
+          <a:blip r:embed="rId3"/>
+          <a:stretch>
+            <a:fillRect/>
+          </a:stretch>
+        </p:blipFill>
+        <p:spPr>
+          <a:xfrm>
+            <a:off x="9986962" y="0"/>
+            <a:ext cx="2379427" cy="1043141"/>
+          </a:xfrm>
+          <a:prstGeom prst="rect">
+            <a:avLst/>
+          </a:prstGeom>
+        </p:spPr>
+      </p:pic>
+      <p:sp>
+        <p:nvSpPr>
+          <p:cNvPr id="3" name="Subtitle 2">
+            <a:extLst>
+              <a:ext uri="{FF2B5EF4-FFF2-40B4-BE49-F238E27FC236}">
+                <a16:creationId xmlns:a16="http://schemas.microsoft.com/office/drawing/2014/main" id="{503384E2-6EF8-0DBD-945B-0F4ABCAD0343}"/>
+              </a:ext>
+            </a:extLst>
+          </p:cNvPr>
+          <p:cNvSpPr>
+            <a:spLocks noGrp="1"/>
+          </p:cNvSpPr>
+          <p:nvPr>
+            <p:ph type="subTitle" idx="1" hasCustomPrompt="1"/>
+          </p:nvPr>
+        </p:nvSpPr>
+        <p:spPr>
+          <a:xfrm>
+            <a:off x="154112" y="3429000"/>
+            <a:ext cx="9144000" cy="588196"/>
+          </a:xfrm>
+        </p:spPr>
+        <p:txBody>
+          <a:bodyPr/>
+          <a:lstStyle>
+            <a:lvl1pPr marL="0" indent="0" algn="l">
+              <a:buNone/>
+              <a:defRPr sz="2400">
+                <a:solidFill>
+                  <a:schemeClr val="accent1">
+                    <a:lumMod val="20000"/>
+                    <a:lumOff val="80000"/>
+                  </a:schemeClr>
+                </a:solidFill>
+              </a:defRPr>
+            </a:lvl1pPr>
+            <a:lvl2pPr marL="457200" indent="0" algn="ctr">
+              <a:buNone/>
+              <a:defRPr sz="2000"/>
+            </a:lvl2pPr>
+            <a:lvl3pPr marL="914400" indent="0" algn="ctr">
+              <a:buNone/>
+              <a:defRPr sz="1800"/>
+            </a:lvl3pPr>
+            <a:lvl4pPr marL="1371600" indent="0" algn="ctr">
+              <a:buNone/>
+              <a:defRPr sz="1600"/>
+            </a:lvl4pPr>
+            <a:lvl5pPr marL="1828800" indent="0" algn="ctr">
+              <a:buNone/>
+              <a:defRPr sz="1600"/>
+            </a:lvl5pPr>
+            <a:lvl6pPr marL="2286000" indent="0" algn="ctr">
+              <a:buNone/>
+              <a:defRPr sz="1600"/>
+            </a:lvl6pPr>
+            <a:lvl7pPr marL="2743200" indent="0" algn="ctr">
+              <a:buNone/>
+              <a:defRPr sz="1600"/>
+            </a:lvl7pPr>
+            <a:lvl8pPr marL="3200400" indent="0" algn="ctr">
+              <a:buNone/>
+              <a:defRPr sz="1600"/>
+            </a:lvl8pPr>
+            <a:lvl9pPr marL="3657600" indent="0" algn="ctr">
+              <a:buNone/>
+              <a:defRPr sz="1600"/>
+            </a:lvl9pPr>
+          </a:lstStyle>
+          <a:p>
+            <a:r>
+              <a:rPr lang="en-US" dirty="0"/>
+              <a:t>Zenith</a:t>
+            </a:r>
+          </a:p>
+        </p:txBody>
+      </p:sp>
+    </p:spTree>
+    <p:extLst>
+      <p:ext uri="{BB962C8B-B14F-4D97-AF65-F5344CB8AC3E}">
+        <p14:creationId xmlns:p14="http://schemas.microsoft.com/office/powerpoint/2010/main" val="2937839878"/>
+      </p:ext>
+    </p:extLst>
+  </p:cSld>
+  <p:clrMapOvr>
+    <a:masterClrMapping/>
+  </p:clrMapOvr>
+</p:sld>
+</file>
+
+<file path=ppt/slides/slide7.xml><?xml version="1.0" encoding="utf-8"?>
+<p:sld xmlns:a="http://schemas.openxmlformats.org/drawingml/2006/main" xmlns:r="http://schemas.openxmlformats.org/officeDocument/2006/relationships" xmlns:p="http://schemas.openxmlformats.org/presentationml/2006/main">
+  <p:cSld>
+    <p:spTree>
+      <p:nvGrpSpPr>
+        <p:cNvPr id="1" name="">
+          <a:extLst>
+            <a:ext uri="{FF2B5EF4-FFF2-40B4-BE49-F238E27FC236}">
+              <a16:creationId xmlns:a16="http://schemas.microsoft.com/office/drawing/2014/main" id="{79E7A349-4053-5DD8-CE45-AA1F0F3BC2BD}"/>
+            </a:ext>
+          </a:extLst>
+        </p:cNvPr>
+        <p:cNvGrpSpPr/>
+        <p:nvPr/>
+      </p:nvGrpSpPr>
+      <p:grpSpPr>
+        <a:xfrm>
+          <a:off x="0" y="0"/>
+          <a:ext cx="0" cy="0"/>
+          <a:chOff x="0" y="0"/>
+          <a:chExt cx="0" cy="0"/>
+        </a:xfrm>
+      </p:grpSpPr>
+      <p:pic>
+        <p:nvPicPr>
+          <p:cNvPr id="16" name="Picture 15" descr="A black background with pink dots&#10;&#10;AI-generated content may be incorrect.">
+            <a:extLst>
+              <a:ext uri="{FF2B5EF4-FFF2-40B4-BE49-F238E27FC236}">
+                <a16:creationId xmlns:a16="http://schemas.microsoft.com/office/drawing/2014/main" id="{9BAB3894-7BD9-5652-0F0A-E02B84BE1E97}"/>
+              </a:ext>
+            </a:extLst>
+          </p:cNvPr>
+          <p:cNvPicPr>
+            <a:picLocks noChangeAspect="1"/>
+          </p:cNvPicPr>
+          <p:nvPr/>
+        </p:nvPicPr>
+        <p:blipFill>
+          <a:blip r:embed="rId2"/>
+          <a:stretch>
+            <a:fillRect/>
+          </a:stretch>
+        </p:blipFill>
+        <p:spPr>
+          <a:xfrm>
+            <a:off x="6096000" y="0"/>
+            <a:ext cx="6858000" cy="6858000"/>
+          </a:xfrm>
+          <a:prstGeom prst="rect">
+            <a:avLst/>
+          </a:prstGeom>
+        </p:spPr>
+      </p:pic>
+      <p:pic>
+        <p:nvPicPr>
+          <p:cNvPr id="15" name="Picture 14" descr="A black background with pink dots&#10;&#10;AI-generated content may be incorrect.">
+            <a:extLst>
+              <a:ext uri="{FF2B5EF4-FFF2-40B4-BE49-F238E27FC236}">
+                <a16:creationId xmlns:a16="http://schemas.microsoft.com/office/drawing/2014/main" id="{F3941C0C-4D1F-2FB1-42E2-BF39E34B65F9}"/>
+              </a:ext>
+            </a:extLst>
+          </p:cNvPr>
+          <p:cNvPicPr>
+            <a:picLocks noChangeAspect="1"/>
+          </p:cNvPicPr>
+          <p:nvPr/>
+        </p:nvPicPr>
+        <p:blipFill>
+          <a:blip r:embed="rId2"/>
+          <a:stretch>
+            <a:fillRect/>
+          </a:stretch>
+        </p:blipFill>
+        <p:spPr>
+          <a:xfrm>
+            <a:off x="0" y="0"/>
+            <a:ext cx="6858000" cy="6858000"/>
+          </a:xfrm>
+          <a:prstGeom prst="rect">
+            <a:avLst/>
+          </a:prstGeom>
+        </p:spPr>
+      </p:pic>
+      <p:sp>
+        <p:nvSpPr>
+          <p:cNvPr id="2" name="Title 1">
+            <a:extLst>
+              <a:ext uri="{FF2B5EF4-FFF2-40B4-BE49-F238E27FC236}">
+                <a16:creationId xmlns:a16="http://schemas.microsoft.com/office/drawing/2014/main" id="{B3092E7E-6347-6574-4960-CD15D3A55939}"/>
+              </a:ext>
+            </a:extLst>
+          </p:cNvPr>
+          <p:cNvSpPr>
+            <a:spLocks noGrp="1"/>
+          </p:cNvSpPr>
+          <p:nvPr>
+            <p:ph type="ctrTitle"/>
+          </p:nvPr>
+        </p:nvSpPr>
+        <p:spPr/>
+        <p:txBody>
+          <a:bodyPr>
+            <a:noAutofit/>
+          </a:bodyPr>
+          <a:lstStyle/>
+          <a:p>
+            <a:r>
+              <a:rPr lang="en-US" sz="7200" dirty="0"/>
+              <a:t>Lumos</a:t>
+            </a:r>
+          </a:p>
+        </p:txBody>
+      </p:sp>
+      <p:sp>
+        <p:nvSpPr>
+          <p:cNvPr id="7" name="Text Placeholder 6">
+            <a:extLst>
+              <a:ext uri="{FF2B5EF4-FFF2-40B4-BE49-F238E27FC236}">
+                <a16:creationId xmlns:a16="http://schemas.microsoft.com/office/drawing/2014/main" id="{44125FB9-AACB-32E9-C914-E3F3196ADAC3}"/>
+              </a:ext>
+            </a:extLst>
+          </p:cNvPr>
+          <p:cNvSpPr>
+            <a:spLocks noGrp="1"/>
+          </p:cNvSpPr>
+          <p:nvPr>
+            <p:ph type="body" sz="quarter" idx="13"/>
+          </p:nvPr>
+        </p:nvSpPr>
+        <p:spPr/>
+        <p:txBody>
+          <a:bodyPr>
+            <a:normAutofit fontScale="77500" lnSpcReduction="20000"/>
+          </a:bodyPr>
+          <a:lstStyle/>
+          <a:p>
+            <a:r>
+              <a:rPr lang="en-US" dirty="0"/>
+              <a:t>Assessment Center Presentation Template</a:t>
+            </a:r>
+          </a:p>
+        </p:txBody>
+      </p:sp>
+      <p:sp>
+        <p:nvSpPr>
+          <p:cNvPr id="8" name="Slide Number Placeholder 7">
+            <a:extLst>
+              <a:ext uri="{FF2B5EF4-FFF2-40B4-BE49-F238E27FC236}">
+                <a16:creationId xmlns:a16="http://schemas.microsoft.com/office/drawing/2014/main" id="{925D31A2-D2DB-9180-5725-628CABA7730E}"/>
+              </a:ext>
+            </a:extLst>
+          </p:cNvPr>
+          <p:cNvSpPr>
+            <a:spLocks noGrp="1"/>
+          </p:cNvSpPr>
+          <p:nvPr>
+            <p:ph type="sldNum" sz="quarter" idx="4294967295"/>
+          </p:nvPr>
+        </p:nvSpPr>
+        <p:spPr>
+          <a:xfrm>
+            <a:off x="10708715" y="6356350"/>
+            <a:ext cx="524479" cy="365125"/>
+          </a:xfrm>
+          <a:prstGeom prst="rect">
+            <a:avLst/>
+          </a:prstGeom>
+        </p:spPr>
+        <p:txBody>
+          <a:bodyPr/>
+          <a:lstStyle/>
+          <a:p>
+            <a:fld id="{777B4535-3FCB-194B-8628-80D28B32D103}" type="slidenum">
+              <a:rPr lang="en-US" smtClean="0"/>
+              <a:t>7</a:t>
+            </a:fld>
+            <a:endParaRPr lang="en-US"/>
+          </a:p>
+        </p:txBody>
+      </p:sp>
+      <p:pic>
+        <p:nvPicPr>
+          <p:cNvPr id="11" name="Picture 10" descr="A white logo on a black background&#10;&#10;AI-generated content may be incorrect.">
+            <a:extLst>
+              <a:ext uri="{FF2B5EF4-FFF2-40B4-BE49-F238E27FC236}">
+                <a16:creationId xmlns:a16="http://schemas.microsoft.com/office/drawing/2014/main" id="{F602579D-DB81-07C9-1CEA-BF01DAF01DDA}"/>
+              </a:ext>
+            </a:extLst>
+          </p:cNvPr>
+          <p:cNvPicPr>
+            <a:picLocks noChangeAspect="1"/>
+          </p:cNvPicPr>
+          <p:nvPr/>
+        </p:nvPicPr>
+        <p:blipFill>
+          <a:blip r:embed="rId3"/>
+          <a:stretch>
+            <a:fillRect/>
+          </a:stretch>
+        </p:blipFill>
+        <p:spPr>
+          <a:xfrm>
+            <a:off x="9986962" y="0"/>
+            <a:ext cx="2379427" cy="1043141"/>
+          </a:xfrm>
+          <a:prstGeom prst="rect">
+            <a:avLst/>
+          </a:prstGeom>
+        </p:spPr>
+      </p:pic>
+      <p:sp>
+        <p:nvSpPr>
+          <p:cNvPr id="3" name="Subtitle 2">
+            <a:extLst>
+              <a:ext uri="{FF2B5EF4-FFF2-40B4-BE49-F238E27FC236}">
+                <a16:creationId xmlns:a16="http://schemas.microsoft.com/office/drawing/2014/main" id="{2C4268C2-BAD3-D62F-759D-38DF743A0789}"/>
+              </a:ext>
+            </a:extLst>
+          </p:cNvPr>
+          <p:cNvSpPr>
+            <a:spLocks noGrp="1"/>
+          </p:cNvSpPr>
+          <p:nvPr>
+            <p:ph type="subTitle" idx="1" hasCustomPrompt="1"/>
+          </p:nvPr>
+        </p:nvSpPr>
+        <p:spPr>
+          <a:xfrm>
+            <a:off x="154112" y="3429000"/>
+            <a:ext cx="9144000" cy="588196"/>
+          </a:xfrm>
+        </p:spPr>
+        <p:txBody>
+          <a:bodyPr/>
+          <a:lstStyle>
+            <a:lvl1pPr marL="0" indent="0" algn="l">
+              <a:buNone/>
+              <a:defRPr sz="2400">
+                <a:solidFill>
+                  <a:schemeClr val="accent1">
+                    <a:lumMod val="20000"/>
+                    <a:lumOff val="80000"/>
+                  </a:schemeClr>
+                </a:solidFill>
+              </a:defRPr>
+            </a:lvl1pPr>
+            <a:lvl2pPr marL="457200" indent="0" algn="ctr">
+              <a:buNone/>
+              <a:defRPr sz="2000"/>
+            </a:lvl2pPr>
+            <a:lvl3pPr marL="914400" indent="0" algn="ctr">
+              <a:buNone/>
+              <a:defRPr sz="1800"/>
+            </a:lvl3pPr>
+            <a:lvl4pPr marL="1371600" indent="0" algn="ctr">
+              <a:buNone/>
+              <a:defRPr sz="1600"/>
+            </a:lvl4pPr>
+            <a:lvl5pPr marL="1828800" indent="0" algn="ctr">
+              <a:buNone/>
+              <a:defRPr sz="1600"/>
+            </a:lvl5pPr>
+            <a:lvl6pPr marL="2286000" indent="0" algn="ctr">
+              <a:buNone/>
+              <a:defRPr sz="1600"/>
+            </a:lvl6pPr>
+            <a:lvl7pPr marL="2743200" indent="0" algn="ctr">
+              <a:buNone/>
+              <a:defRPr sz="1600"/>
+            </a:lvl7pPr>
+            <a:lvl8pPr marL="3200400" indent="0" algn="ctr">
+              <a:buNone/>
+              <a:defRPr sz="1600"/>
+            </a:lvl8pPr>
+            <a:lvl9pPr marL="3657600" indent="0" algn="ctr">
+              <a:buNone/>
+              <a:defRPr sz="1600"/>
+            </a:lvl9pPr>
+          </a:lstStyle>
+          <a:p>
+            <a:r>
+              <a:rPr lang="en-US" dirty="0"/>
+              <a:t>Zenith</a:t>
+            </a:r>
+          </a:p>
+        </p:txBody>
+      </p:sp>
+    </p:spTree>
+    <p:extLst>
+      <p:ext uri="{BB962C8B-B14F-4D97-AF65-F5344CB8AC3E}">
+        <p14:creationId xmlns:p14="http://schemas.microsoft.com/office/powerpoint/2010/main" val="355990649"/>
+      </p:ext>
+    </p:extLst>
+  </p:cSld>
+  <p:clrMapOvr>
+    <a:masterClrMapping/>
+  </p:clrMapOvr>
+</p:sld>
+</file>
+
+<file path=ppt/slides/slide8.xml><?xml version="1.0" encoding="utf-8"?>
+<p:sld xmlns:a="http://schemas.openxmlformats.org/drawingml/2006/main" xmlns:r="http://schemas.openxmlformats.org/officeDocument/2006/relationships" xmlns:p="http://schemas.openxmlformats.org/presentationml/2006/main">
+  <p:cSld>
+    <p:spTree>
+      <p:nvGrpSpPr>
+        <p:cNvPr id="1" name="">
+          <a:extLst>
+            <a:ext uri="{FF2B5EF4-FFF2-40B4-BE49-F238E27FC236}">
+              <a16:creationId xmlns:a16="http://schemas.microsoft.com/office/drawing/2014/main" id="{00C40A1A-3A09-FB19-83F2-648893DFC2D6}"/>
+            </a:ext>
+          </a:extLst>
+        </p:cNvPr>
+        <p:cNvGrpSpPr/>
+        <p:nvPr/>
+      </p:nvGrpSpPr>
+      <p:grpSpPr>
+        <a:xfrm>
+          <a:off x="0" y="0"/>
+          <a:ext cx="0" cy="0"/>
+          <a:chOff x="0" y="0"/>
+          <a:chExt cx="0" cy="0"/>
+        </a:xfrm>
+      </p:grpSpPr>
+      <p:pic>
+        <p:nvPicPr>
+          <p:cNvPr id="16" name="Picture 15" descr="A black background with pink dots&#10;&#10;AI-generated content may be incorrect.">
+            <a:extLst>
+              <a:ext uri="{FF2B5EF4-FFF2-40B4-BE49-F238E27FC236}">
+                <a16:creationId xmlns:a16="http://schemas.microsoft.com/office/drawing/2014/main" id="{FE504DD2-52F6-0B8B-D639-C5D12EBA67CF}"/>
+              </a:ext>
+            </a:extLst>
+          </p:cNvPr>
+          <p:cNvPicPr>
+            <a:picLocks noChangeAspect="1"/>
+          </p:cNvPicPr>
+          <p:nvPr/>
+        </p:nvPicPr>
+        <p:blipFill>
+          <a:blip r:embed="rId2"/>
+          <a:stretch>
+            <a:fillRect/>
+          </a:stretch>
+        </p:blipFill>
+        <p:spPr>
+          <a:xfrm>
+            <a:off x="6096000" y="0"/>
+            <a:ext cx="6858000" cy="6858000"/>
+          </a:xfrm>
+          <a:prstGeom prst="rect">
+            <a:avLst/>
+          </a:prstGeom>
+        </p:spPr>
+      </p:pic>
+      <p:pic>
+        <p:nvPicPr>
+          <p:cNvPr id="15" name="Picture 14" descr="A black background with pink dots&#10;&#10;AI-generated content may be incorrect.">
+            <a:extLst>
+              <a:ext uri="{FF2B5EF4-FFF2-40B4-BE49-F238E27FC236}">
+                <a16:creationId xmlns:a16="http://schemas.microsoft.com/office/drawing/2014/main" id="{2C18E628-50D6-DC65-B0BE-135147C8D039}"/>
+              </a:ext>
+            </a:extLst>
+          </p:cNvPr>
+          <p:cNvPicPr>
+            <a:picLocks noChangeAspect="1"/>
+          </p:cNvPicPr>
+          <p:nvPr/>
+        </p:nvPicPr>
+        <p:blipFill>
+          <a:blip r:embed="rId2"/>
+          <a:stretch>
+            <a:fillRect/>
+          </a:stretch>
+        </p:blipFill>
+        <p:spPr>
+          <a:xfrm>
+            <a:off x="0" y="0"/>
+            <a:ext cx="6858000" cy="6858000"/>
+          </a:xfrm>
+          <a:prstGeom prst="rect">
+            <a:avLst/>
+          </a:prstGeom>
+        </p:spPr>
+      </p:pic>
+      <p:sp>
+        <p:nvSpPr>
+          <p:cNvPr id="2" name="Title 1">
+            <a:extLst>
+              <a:ext uri="{FF2B5EF4-FFF2-40B4-BE49-F238E27FC236}">
+                <a16:creationId xmlns:a16="http://schemas.microsoft.com/office/drawing/2014/main" id="{3D821C27-05B8-74A1-FCDA-693CD10E217C}"/>
+              </a:ext>
+            </a:extLst>
+          </p:cNvPr>
+          <p:cNvSpPr>
+            <a:spLocks noGrp="1"/>
+          </p:cNvSpPr>
+          <p:nvPr>
+            <p:ph type="ctrTitle"/>
+          </p:nvPr>
+        </p:nvSpPr>
+        <p:spPr/>
+        <p:txBody>
+          <a:bodyPr>
+            <a:noAutofit/>
+          </a:bodyPr>
+          <a:lstStyle/>
+          <a:p>
+            <a:r>
+              <a:rPr lang="en-US" sz="7200" dirty="0"/>
+              <a:t>Lumos</a:t>
+            </a:r>
+          </a:p>
+        </p:txBody>
+      </p:sp>
+      <p:sp>
+        <p:nvSpPr>
+          <p:cNvPr id="7" name="Text Placeholder 6">
+            <a:extLst>
+              <a:ext uri="{FF2B5EF4-FFF2-40B4-BE49-F238E27FC236}">
+                <a16:creationId xmlns:a16="http://schemas.microsoft.com/office/drawing/2014/main" id="{74E40288-862F-8870-923D-D4788674E557}"/>
+              </a:ext>
+            </a:extLst>
+          </p:cNvPr>
+          <p:cNvSpPr>
+            <a:spLocks noGrp="1"/>
+          </p:cNvSpPr>
+          <p:nvPr>
+            <p:ph type="body" sz="quarter" idx="13"/>
+          </p:nvPr>
+        </p:nvSpPr>
+        <p:spPr/>
+        <p:txBody>
+          <a:bodyPr>
+            <a:normAutofit fontScale="77500" lnSpcReduction="20000"/>
+          </a:bodyPr>
+          <a:lstStyle/>
+          <a:p>
+            <a:r>
+              <a:rPr lang="en-US" dirty="0"/>
+              <a:t>Assessment Center Presentation Template</a:t>
+            </a:r>
+          </a:p>
+        </p:txBody>
+      </p:sp>
+      <p:sp>
+        <p:nvSpPr>
+          <p:cNvPr id="8" name="Slide Number Placeholder 7">
+            <a:extLst>
+              <a:ext uri="{FF2B5EF4-FFF2-40B4-BE49-F238E27FC236}">
+                <a16:creationId xmlns:a16="http://schemas.microsoft.com/office/drawing/2014/main" id="{8B20061E-8B66-604D-24DE-5B1E3D6A5BEA}"/>
+              </a:ext>
+            </a:extLst>
+          </p:cNvPr>
+          <p:cNvSpPr>
+            <a:spLocks noGrp="1"/>
+          </p:cNvSpPr>
+          <p:nvPr>
+            <p:ph type="sldNum" sz="quarter" idx="4294967295"/>
+          </p:nvPr>
+        </p:nvSpPr>
+        <p:spPr>
+          <a:xfrm>
+            <a:off x="10708715" y="6356350"/>
+            <a:ext cx="524479" cy="365125"/>
+          </a:xfrm>
+          <a:prstGeom prst="rect">
+            <a:avLst/>
+          </a:prstGeom>
+        </p:spPr>
+        <p:txBody>
+          <a:bodyPr/>
+          <a:lstStyle/>
+          <a:p>
+            <a:fld id="{777B4535-3FCB-194B-8628-80D28B32D103}" type="slidenum">
+              <a:rPr lang="en-US" smtClean="0"/>
+              <a:t>8</a:t>
+            </a:fld>
+            <a:endParaRPr lang="en-US"/>
+          </a:p>
+        </p:txBody>
+      </p:sp>
+      <p:pic>
+        <p:nvPicPr>
+          <p:cNvPr id="11" name="Picture 10" descr="A white logo on a black background&#10;&#10;AI-generated content may be incorrect.">
+            <a:extLst>
+              <a:ext uri="{FF2B5EF4-FFF2-40B4-BE49-F238E27FC236}">
+                <a16:creationId xmlns:a16="http://schemas.microsoft.com/office/drawing/2014/main" id="{B2A1E976-5ED2-DC7D-8D5C-4BE869A2B311}"/>
+              </a:ext>
+            </a:extLst>
+          </p:cNvPr>
+          <p:cNvPicPr>
+            <a:picLocks noChangeAspect="1"/>
+          </p:cNvPicPr>
+          <p:nvPr/>
+        </p:nvPicPr>
+        <p:blipFill>
+          <a:blip r:embed="rId3"/>
+          <a:stretch>
+            <a:fillRect/>
+          </a:stretch>
+        </p:blipFill>
+        <p:spPr>
+          <a:xfrm>
+            <a:off x="9986962" y="0"/>
+            <a:ext cx="2379427" cy="1043141"/>
+          </a:xfrm>
+          <a:prstGeom prst="rect">
+            <a:avLst/>
+          </a:prstGeom>
+        </p:spPr>
+      </p:pic>
+      <p:sp>
+        <p:nvSpPr>
+          <p:cNvPr id="3" name="Subtitle 2">
+            <a:extLst>
+              <a:ext uri="{FF2B5EF4-FFF2-40B4-BE49-F238E27FC236}">
+                <a16:creationId xmlns:a16="http://schemas.microsoft.com/office/drawing/2014/main" id="{03D8C10B-FBEC-586C-316E-915B83C0ABC2}"/>
+              </a:ext>
+            </a:extLst>
+          </p:cNvPr>
+          <p:cNvSpPr>
+            <a:spLocks noGrp="1"/>
+          </p:cNvSpPr>
+          <p:nvPr>
+            <p:ph type="subTitle" idx="1" hasCustomPrompt="1"/>
+          </p:nvPr>
+        </p:nvSpPr>
+        <p:spPr>
+          <a:xfrm>
+            <a:off x="154112" y="3429000"/>
+            <a:ext cx="9144000" cy="588196"/>
+          </a:xfrm>
+        </p:spPr>
+        <p:txBody>
+          <a:bodyPr/>
+          <a:lstStyle>
+            <a:lvl1pPr marL="0" indent="0" algn="l">
+              <a:buNone/>
+              <a:defRPr sz="2400">
+                <a:solidFill>
+                  <a:schemeClr val="accent1">
+                    <a:lumMod val="20000"/>
+                    <a:lumOff val="80000"/>
+                  </a:schemeClr>
+                </a:solidFill>
+              </a:defRPr>
+            </a:lvl1pPr>
+            <a:lvl2pPr marL="457200" indent="0" algn="ctr">
+              <a:buNone/>
+              <a:defRPr sz="2000"/>
+            </a:lvl2pPr>
+            <a:lvl3pPr marL="914400" indent="0" algn="ctr">
+              <a:buNone/>
+              <a:defRPr sz="1800"/>
+            </a:lvl3pPr>
+            <a:lvl4pPr marL="1371600" indent="0" algn="ctr">
+              <a:buNone/>
+              <a:defRPr sz="1600"/>
+            </a:lvl4pPr>
+            <a:lvl5pPr marL="1828800" indent="0" algn="ctr">
+              <a:buNone/>
+              <a:defRPr sz="1600"/>
+            </a:lvl5pPr>
+            <a:lvl6pPr marL="2286000" indent="0" algn="ctr">
+              <a:buNone/>
+              <a:defRPr sz="1600"/>
+            </a:lvl6pPr>
+            <a:lvl7pPr marL="2743200" indent="0" algn="ctr">
+              <a:buNone/>
+              <a:defRPr sz="1600"/>
+            </a:lvl7pPr>
+            <a:lvl8pPr marL="3200400" indent="0" algn="ctr">
+              <a:buNone/>
+              <a:defRPr sz="1600"/>
+            </a:lvl8pPr>
+            <a:lvl9pPr marL="3657600" indent="0" algn="ctr">
+              <a:buNone/>
+              <a:defRPr sz="1600"/>
+            </a:lvl9pPr>
+          </a:lstStyle>
+          <a:p>
+            <a:r>
+              <a:rPr lang="en-US" dirty="0"/>
+              <a:t>Zenith</a:t>
+            </a:r>
+          </a:p>
+        </p:txBody>
+      </p:sp>
+    </p:spTree>
+    <p:extLst>
+      <p:ext uri="{BB962C8B-B14F-4D97-AF65-F5344CB8AC3E}">
+        <p14:creationId xmlns:p14="http://schemas.microsoft.com/office/powerpoint/2010/main" val="548078019"/>
+      </p:ext>
+    </p:extLst>
+  </p:cSld>
+  <p:clrMapOvr>
+    <a:masterClrMapping/>
+  </p:clrMapOvr>
+</p:sld>
+</file>
+
+<file path=ppt/slides/slide9.xml><?xml version="1.0" encoding="utf-8"?>
+<p:sld xmlns:a="http://schemas.openxmlformats.org/drawingml/2006/main" xmlns:r="http://schemas.openxmlformats.org/officeDocument/2006/relationships" xmlns:p="http://schemas.openxmlformats.org/presentationml/2006/main">
+  <p:cSld>
+    <p:spTree>
+      <p:nvGrpSpPr>
+        <p:cNvPr id="1" name="">
+          <a:extLst>
+            <a:ext uri="{FF2B5EF4-FFF2-40B4-BE49-F238E27FC236}">
+              <a16:creationId xmlns:a16="http://schemas.microsoft.com/office/drawing/2014/main" id="{4EBCD747-5714-E314-0106-7E9758FDC145}"/>
+            </a:ext>
+          </a:extLst>
+        </p:cNvPr>
+        <p:cNvGrpSpPr/>
+        <p:nvPr/>
+      </p:nvGrpSpPr>
+      <p:grpSpPr>
+        <a:xfrm>
+          <a:off x="0" y="0"/>
+          <a:ext cx="0" cy="0"/>
+          <a:chOff x="0" y="0"/>
+          <a:chExt cx="0" cy="0"/>
+        </a:xfrm>
+      </p:grpSpPr>
+      <p:pic>
+        <p:nvPicPr>
+          <p:cNvPr id="16" name="Picture 15" descr="A black background with pink dots&#10;&#10;AI-generated content may be incorrect.">
+            <a:extLst>
+              <a:ext uri="{FF2B5EF4-FFF2-40B4-BE49-F238E27FC236}">
+                <a16:creationId xmlns:a16="http://schemas.microsoft.com/office/drawing/2014/main" id="{FE0DF8BD-2BF3-9814-296E-19D8F6EE5E02}"/>
+              </a:ext>
+            </a:extLst>
+          </p:cNvPr>
+          <p:cNvPicPr>
+            <a:picLocks noChangeAspect="1"/>
+          </p:cNvPicPr>
+          <p:nvPr/>
+        </p:nvPicPr>
+        <p:blipFill>
+          <a:blip r:embed="rId2"/>
+          <a:stretch>
+            <a:fillRect/>
+          </a:stretch>
+        </p:blipFill>
+        <p:spPr>
+          <a:xfrm>
+            <a:off x="6096000" y="0"/>
+            <a:ext cx="6858000" cy="6858000"/>
+          </a:xfrm>
+          <a:prstGeom prst="rect">
+            <a:avLst/>
+          </a:prstGeom>
+        </p:spPr>
+      </p:pic>
+      <p:pic>
+        <p:nvPicPr>
+          <p:cNvPr id="15" name="Picture 14" descr="A black background with pink dots&#10;&#10;AI-generated content may be incorrect.">
+            <a:extLst>
+              <a:ext uri="{FF2B5EF4-FFF2-40B4-BE49-F238E27FC236}">
+                <a16:creationId xmlns:a16="http://schemas.microsoft.com/office/drawing/2014/main" id="{040F1CC5-91FA-6364-1721-5363DB0E358C}"/>
+              </a:ext>
+            </a:extLst>
+          </p:cNvPr>
+          <p:cNvPicPr>
+            <a:picLocks noChangeAspect="1"/>
+          </p:cNvPicPr>
+          <p:nvPr/>
+        </p:nvPicPr>
+        <p:blipFill>
+          <a:blip r:embed="rId2"/>
+          <a:stretch>
+            <a:fillRect/>
+          </a:stretch>
+        </p:blipFill>
+        <p:spPr>
+          <a:xfrm>
+            <a:off x="0" y="0"/>
+            <a:ext cx="6858000" cy="6858000"/>
+          </a:xfrm>
+          <a:prstGeom prst="rect">
+            <a:avLst/>
+          </a:prstGeom>
+        </p:spPr>
+      </p:pic>
+      <p:sp>
+        <p:nvSpPr>
+          <p:cNvPr id="2" name="Title 1">
+            <a:extLst>
+              <a:ext uri="{FF2B5EF4-FFF2-40B4-BE49-F238E27FC236}">
+                <a16:creationId xmlns:a16="http://schemas.microsoft.com/office/drawing/2014/main" id="{15DCADE9-0622-AD85-4F6F-D568559050E1}"/>
+              </a:ext>
+            </a:extLst>
+          </p:cNvPr>
+          <p:cNvSpPr>
+            <a:spLocks noGrp="1"/>
+          </p:cNvSpPr>
+          <p:nvPr>
+            <p:ph type="ctrTitle"/>
+          </p:nvPr>
+        </p:nvSpPr>
+        <p:spPr/>
+        <p:txBody>
+          <a:bodyPr>
+            <a:noAutofit/>
+          </a:bodyPr>
+          <a:lstStyle/>
+          <a:p>
+            <a:r>
+              <a:rPr lang="en-US" sz="7200" dirty="0"/>
+              <a:t>Lumos</a:t>
+            </a:r>
+          </a:p>
+        </p:txBody>
+      </p:sp>
+      <p:sp>
+        <p:nvSpPr>
+          <p:cNvPr id="7" name="Text Placeholder 6">
+            <a:extLst>
+              <a:ext uri="{FF2B5EF4-FFF2-40B4-BE49-F238E27FC236}">
+                <a16:creationId xmlns:a16="http://schemas.microsoft.com/office/drawing/2014/main" id="{E1FA98B1-4639-89D6-B959-80D63E22E6D1}"/>
+              </a:ext>
+            </a:extLst>
+          </p:cNvPr>
+          <p:cNvSpPr>
+            <a:spLocks noGrp="1"/>
+          </p:cNvSpPr>
+          <p:nvPr>
+            <p:ph type="body" sz="quarter" idx="13"/>
+          </p:nvPr>
+        </p:nvSpPr>
+        <p:spPr/>
+        <p:txBody>
+          <a:bodyPr>
+            <a:normAutofit fontScale="77500" lnSpcReduction="20000"/>
+          </a:bodyPr>
+          <a:lstStyle/>
+          <a:p>
+            <a:r>
+              <a:rPr lang="en-US" dirty="0"/>
+              <a:t>Assessment Center Presentation Template</a:t>
+            </a:r>
+          </a:p>
+        </p:txBody>
+      </p:sp>
+      <p:sp>
+        <p:nvSpPr>
+          <p:cNvPr id="8" name="Slide Number Placeholder 7">
+            <a:extLst>
+              <a:ext uri="{FF2B5EF4-FFF2-40B4-BE49-F238E27FC236}">
+                <a16:creationId xmlns:a16="http://schemas.microsoft.com/office/drawing/2014/main" id="{3113BBB8-B589-4630-89BB-1CC4556C39A8}"/>
+              </a:ext>
+            </a:extLst>
+          </p:cNvPr>
+          <p:cNvSpPr>
+            <a:spLocks noGrp="1"/>
+          </p:cNvSpPr>
+          <p:nvPr>
+            <p:ph type="sldNum" sz="quarter" idx="4294967295"/>
+          </p:nvPr>
+        </p:nvSpPr>
+        <p:spPr>
+          <a:xfrm>
+            <a:off x="10708715" y="6356350"/>
+            <a:ext cx="524479" cy="365125"/>
+          </a:xfrm>
+          <a:prstGeom prst="rect">
+            <a:avLst/>
+          </a:prstGeom>
+        </p:spPr>
+        <p:txBody>
+          <a:bodyPr/>
+          <a:lstStyle/>
+          <a:p>
+            <a:fld id="{777B4535-3FCB-194B-8628-80D28B32D103}" type="slidenum">
+              <a:rPr lang="en-US" smtClean="0"/>
+              <a:t>9</a:t>
+            </a:fld>
+            <a:endParaRPr lang="en-US"/>
+          </a:p>
+        </p:txBody>
+      </p:sp>
+      <p:pic>
+        <p:nvPicPr>
+          <p:cNvPr id="11" name="Picture 10" descr="A white logo on a black background&#10;&#10;AI-generated content may be incorrect.">
+            <a:extLst>
+              <a:ext uri="{FF2B5EF4-FFF2-40B4-BE49-F238E27FC236}">
+                <a16:creationId xmlns:a16="http://schemas.microsoft.com/office/drawing/2014/main" id="{65FB153D-47D5-918C-5323-0DE7B095203C}"/>
+              </a:ext>
+            </a:extLst>
+          </p:cNvPr>
+          <p:cNvPicPr>
+            <a:picLocks noChangeAspect="1"/>
+          </p:cNvPicPr>
+          <p:nvPr/>
+        </p:nvPicPr>
+        <p:blipFill>
+          <a:blip r:embed="rId3"/>
+          <a:stretch>
+            <a:fillRect/>
+          </a:stretch>
+        </p:blipFill>
+        <p:spPr>
+          <a:xfrm>
+            <a:off x="9986962" y="0"/>
+            <a:ext cx="2379427" cy="1043141"/>
+          </a:xfrm>
+          <a:prstGeom prst="rect">
+            <a:avLst/>
+          </a:prstGeom>
+        </p:spPr>
+      </p:pic>
+      <p:sp>
+        <p:nvSpPr>
+          <p:cNvPr id="3" name="Subtitle 2">
+            <a:extLst>
+              <a:ext uri="{FF2B5EF4-FFF2-40B4-BE49-F238E27FC236}">
+                <a16:creationId xmlns:a16="http://schemas.microsoft.com/office/drawing/2014/main" id="{7E603290-043D-75CD-2E1C-6F436B091918}"/>
+              </a:ext>
+            </a:extLst>
+          </p:cNvPr>
+          <p:cNvSpPr>
+            <a:spLocks noGrp="1"/>
+          </p:cNvSpPr>
+          <p:nvPr>
+            <p:ph type="subTitle" idx="1" hasCustomPrompt="1"/>
+          </p:nvPr>
+        </p:nvSpPr>
+        <p:spPr>
+          <a:xfrm>
+            <a:off x="154112" y="3429000"/>
+            <a:ext cx="9144000" cy="588196"/>
+          </a:xfrm>
+        </p:spPr>
+        <p:txBody>
+          <a:bodyPr/>
+          <a:lstStyle>
+            <a:lvl1pPr marL="0" indent="0" algn="l">
+              <a:buNone/>
+              <a:defRPr sz="2400">
+                <a:solidFill>
+                  <a:schemeClr val="accent1">
+                    <a:lumMod val="20000"/>
+                    <a:lumOff val="80000"/>
+                  </a:schemeClr>
+                </a:solidFill>
+              </a:defRPr>
+            </a:lvl1pPr>
+            <a:lvl2pPr marL="457200" indent="0" algn="ctr">
+              <a:buNone/>
+              <a:defRPr sz="2000"/>
+            </a:lvl2pPr>
+            <a:lvl3pPr marL="914400" indent="0" algn="ctr">
+              <a:buNone/>
+              <a:defRPr sz="1800"/>
+            </a:lvl3pPr>
+            <a:lvl4pPr marL="1371600" indent="0" algn="ctr">
+              <a:buNone/>
+              <a:defRPr sz="1600"/>
+            </a:lvl4pPr>
+            <a:lvl5pPr marL="1828800" indent="0" algn="ctr">
+              <a:buNone/>
+              <a:defRPr sz="1600"/>
+            </a:lvl5pPr>
+            <a:lvl6pPr marL="2286000" indent="0" algn="ctr">
+              <a:buNone/>
+              <a:defRPr sz="1600"/>
+            </a:lvl6pPr>
+            <a:lvl7pPr marL="2743200" indent="0" algn="ctr">
+              <a:buNone/>
+              <a:defRPr sz="1600"/>
+            </a:lvl7pPr>
+            <a:lvl8pPr marL="3200400" indent="0" algn="ctr">
+              <a:buNone/>
+              <a:defRPr sz="1600"/>
+            </a:lvl8pPr>
+            <a:lvl9pPr marL="3657600" indent="0" algn="ctr">
+              <a:buNone/>
+              <a:defRPr sz="1600"/>
+            </a:lvl9pPr>
+          </a:lstStyle>
+          <a:p>
+            <a:r>
+              <a:rPr lang="en-US" dirty="0"/>
+              <a:t>Zenith</a:t>
+            </a:r>
+          </a:p>
+        </p:txBody>
+      </p:sp>
+    </p:spTree>
+    <p:extLst>
+      <p:ext uri="{BB962C8B-B14F-4D97-AF65-F5344CB8AC3E}">
+        <p14:creationId xmlns:p14="http://schemas.microsoft.com/office/powerpoint/2010/main" val="891543252"/>
       </p:ext>
     </p:extLst>
   </p:cSld>
@@ -7945,6 +11874,17 @@
 </file>
 
 <file path=customXml/item1.xml><?xml version="1.0" encoding="utf-8"?>
+<p:properties xmlns:p="http://schemas.microsoft.com/office/2006/metadata/properties" xmlns:xsi="http://www.w3.org/2001/XMLSchema-instance" xmlns:pc="http://schemas.microsoft.com/office/infopath/2007/PartnerControls">
+  <documentManagement>
+    <lcf76f155ced4ddcb4097134ff3c332f xmlns="e92156f5-247e-45a6-a807-9e9922d34555">
+      <Terms xmlns="http://schemas.microsoft.com/office/infopath/2007/PartnerControls"/>
+    </lcf76f155ced4ddcb4097134ff3c332f>
+    <TaxCatchAll xmlns="cea3e9ea-33ed-430f-a910-2edc2d7a5bd3" xsi:nil="true"/>
+  </documentManagement>
+</p:properties>
+</file>
+
+<file path=customXml/item2.xml><?xml version="1.0" encoding="utf-8"?>
 <ct:contentTypeSchema xmlns:ct="http://schemas.microsoft.com/office/2006/metadata/contentType" xmlns:ma="http://schemas.microsoft.com/office/2006/metadata/properties/metaAttributes" ct:_="" ma:_="" ma:contentTypeName="Dokument" ma:contentTypeID="0x010100EF111F083D73A5419FE22528E28A2712" ma:contentTypeVersion="18" ma:contentTypeDescription="Ein neues Dokument erstellen." ma:contentTypeScope="" ma:versionID="93c251434189864e466509373cac2496">
   <xsd:schema xmlns:xsd="http://www.w3.org/2001/XMLSchema" xmlns:xs="http://www.w3.org/2001/XMLSchema" xmlns:p="http://schemas.microsoft.com/office/2006/metadata/properties" xmlns:ns2="e92156f5-247e-45a6-a807-9e9922d34555" xmlns:ns3="cea3e9ea-33ed-430f-a910-2edc2d7a5bd3" targetNamespace="http://schemas.microsoft.com/office/2006/metadata/properties" ma:root="true" ma:fieldsID="094e832184edb820f74aa24b2c90162c" ns2:_="" ns3:_="">
     <xsd:import namespace="e92156f5-247e-45a6-a807-9e9922d34555"/>
@@ -8199,17 +12139,6 @@
 </ct:contentTypeSchema>
 </file>
 
-<file path=customXml/item2.xml><?xml version="1.0" encoding="utf-8"?>
-<p:properties xmlns:p="http://schemas.microsoft.com/office/2006/metadata/properties" xmlns:xsi="http://www.w3.org/2001/XMLSchema-instance" xmlns:pc="http://schemas.microsoft.com/office/infopath/2007/PartnerControls">
-  <documentManagement>
-    <lcf76f155ced4ddcb4097134ff3c332f xmlns="e92156f5-247e-45a6-a807-9e9922d34555">
-      <Terms xmlns="http://schemas.microsoft.com/office/infopath/2007/PartnerControls"/>
-    </lcf76f155ced4ddcb4097134ff3c332f>
-    <TaxCatchAll xmlns="cea3e9ea-33ed-430f-a910-2edc2d7a5bd3" xsi:nil="true"/>
-  </documentManagement>
-</p:properties>
-</file>
-
 <file path=customXml/item3.xml><?xml version="1.0" encoding="utf-8"?>
 <?mso-contentType ?>
 <FormTemplates xmlns="http://schemas.microsoft.com/sharepoint/v3/contenttype/forms">
@@ -8220,6 +12149,23 @@
 </file>
 
 <file path=customXml/itemProps1.xml><?xml version="1.0" encoding="utf-8"?>
+<ds:datastoreItem xmlns:ds="http://schemas.openxmlformats.org/officeDocument/2006/customXml" ds:itemID="{0DA6F9C4-2D13-4EFB-A3F6-36B72ADD08CE}">
+  <ds:schemaRefs>
+    <ds:schemaRef ds:uri="cea3e9ea-33ed-430f-a910-2edc2d7a5bd3"/>
+    <ds:schemaRef ds:uri="e92156f5-247e-45a6-a807-9e9922d34555"/>
+    <ds:schemaRef ds:uri="http://purl.org/dc/dcmitype/"/>
+    <ds:schemaRef ds:uri="http://purl.org/dc/elements/1.1/"/>
+    <ds:schemaRef ds:uri="http://purl.org/dc/terms/"/>
+    <ds:schemaRef ds:uri="http://schemas.microsoft.com/office/2006/documentManagement/types"/>
+    <ds:schemaRef ds:uri="http://schemas.microsoft.com/office/2006/metadata/properties"/>
+    <ds:schemaRef ds:uri="http://schemas.microsoft.com/office/infopath/2007/PartnerControls"/>
+    <ds:schemaRef ds:uri="http://schemas.openxmlformats.org/package/2006/metadata/core-properties"/>
+    <ds:schemaRef ds:uri="http://www.w3.org/XML/1998/namespace"/>
+  </ds:schemaRefs>
+</ds:datastoreItem>
+</file>
+
+<file path=customXml/itemProps2.xml><?xml version="1.0" encoding="utf-8"?>
 <ds:datastoreItem xmlns:ds="http://schemas.openxmlformats.org/officeDocument/2006/customXml" ds:itemID="{5418AA24-5DF3-43A3-87E3-388FE3C05D4C}">
   <ds:schemaRefs>
     <ds:schemaRef ds:uri="cea3e9ea-33ed-430f-a910-2edc2d7a5bd3"/>
@@ -8238,23 +12184,6 @@
 </ds:datastoreItem>
 </file>
 
-<file path=customXml/itemProps2.xml><?xml version="1.0" encoding="utf-8"?>
-<ds:datastoreItem xmlns:ds="http://schemas.openxmlformats.org/officeDocument/2006/customXml" ds:itemID="{0DA6F9C4-2D13-4EFB-A3F6-36B72ADD08CE}">
-  <ds:schemaRefs>
-    <ds:schemaRef ds:uri="cea3e9ea-33ed-430f-a910-2edc2d7a5bd3"/>
-    <ds:schemaRef ds:uri="e92156f5-247e-45a6-a807-9e9922d34555"/>
-    <ds:schemaRef ds:uri="http://purl.org/dc/dcmitype/"/>
-    <ds:schemaRef ds:uri="http://purl.org/dc/elements/1.1/"/>
-    <ds:schemaRef ds:uri="http://purl.org/dc/terms/"/>
-    <ds:schemaRef ds:uri="http://schemas.microsoft.com/office/2006/documentManagement/types"/>
-    <ds:schemaRef ds:uri="http://schemas.microsoft.com/office/2006/metadata/properties"/>
-    <ds:schemaRef ds:uri="http://schemas.microsoft.com/office/infopath/2007/PartnerControls"/>
-    <ds:schemaRef ds:uri="http://schemas.openxmlformats.org/package/2006/metadata/core-properties"/>
-    <ds:schemaRef ds:uri="http://www.w3.org/XML/1998/namespace"/>
-  </ds:schemaRefs>
-</ds:datastoreItem>
-</file>
-
 <file path=customXml/itemProps3.xml><?xml version="1.0" encoding="utf-8"?>
 <ds:datastoreItem xmlns:ds="http://schemas.openxmlformats.org/officeDocument/2006/customXml" ds:itemID="{42EB3BDB-C03C-4056-B236-09FA85AE48C5}">
   <ds:schemaRefs>

</xml_diff>